<commit_message>
Add Do and Don'ts slide to Blind Box Thermal deck
Co-Authored-By: Claude Sonnet 5.5 <noreply@anthropic.com>
Claude-Session: https://claude.ai/code/session_01WvUriRkWqtmHorCL8uL8C7
</commit_message>
<xml_diff>
--- a/Instruksi_Display_Blind_Box_Thermal.pptx
+++ b/Instruksi_Display_Blind_Box_Thermal.pptx
@@ -12,9 +12,10 @@
     <p:sldId id="260" r:id="rId6"/>
     <p:sldId id="261" r:id="rId7"/>
     <p:sldId id="262" r:id="rId8"/>
+    <p:sldId id="263" r:id="rId9"/>
   </p:sldIdLst>
   <p:notesMasterIdLst>
-    <p:notesMasterId r:id="rId9"/>
+    <p:notesMasterId r:id="rId10"/>
   </p:notesMasterIdLst>
   <p:sldSz cx="12192000" cy="6858000"/>
   <p:notesSz cx="6858000" cy="12192000"/>
@@ -1060,6 +1061,94 @@
             <a:fld id="{F7021451-1387-4CA6-816F-3879F97B5CBC}" type="slidenum">
               <a:rPr lang="en-US"/>
               <a:t>7</a:t>
+            </a:fld>
+            <a:endParaRPr lang="en-US"/>
+          </a:p>
+        </p:txBody>
+      </p:sp>
+    </p:spTree>
+    <p:extLst>
+      <p:ext uri="{BB962C8B-B14F-4D97-AF65-F5344CB8AC3E}">
+        <p14:creationId xmlns:p14="http://schemas.microsoft.com/office/powerpoint/2010/main" val="1024086991"/>
+      </p:ext>
+    </p:extLst>
+  </p:cSld>
+  <p:clrMapOvr>
+    <a:masterClrMapping/>
+  </p:clrMapOvr>
+</p:notes>
+</file>
+
+<file path=ppt/notesSlides/notesSlide8.xml><?xml version="1.0" encoding="utf-8"?>
+<p:notes xmlns:a="http://schemas.openxmlformats.org/drawingml/2006/main" xmlns:r="http://schemas.openxmlformats.org/officeDocument/2006/relationships" xmlns:p="http://schemas.openxmlformats.org/presentationml/2006/main">
+  <p:cSld>
+    <p:spTree>
+      <p:nvGrpSpPr>
+        <p:cNvPr id="1" name=""/>
+        <p:cNvGrpSpPr/>
+        <p:nvPr/>
+      </p:nvGrpSpPr>
+      <p:grpSpPr>
+        <a:xfrm>
+          <a:off x="0" y="0"/>
+          <a:ext cx="0" cy="0"/>
+          <a:chOff x="0" y="0"/>
+          <a:chExt cx="0" cy="0"/>
+        </a:xfrm>
+      </p:grpSpPr>
+      <p:sp>
+        <p:nvSpPr>
+          <p:cNvPr id="2" name="Slide Image Placeholder 1"/>
+          <p:cNvSpPr>
+            <a:spLocks noGrp="1" noRot="1" noChangeAspect="1"/>
+          </p:cNvSpPr>
+          <p:nvPr>
+            <p:ph type="sldImg"/>
+          </p:nvPr>
+        </p:nvSpPr>
+        <p:spPr/>
+      </p:sp>
+      <p:sp>
+        <p:nvSpPr>
+          <p:cNvPr id="3" name="Notes Placeholder 2"/>
+          <p:cNvSpPr>
+            <a:spLocks noGrp="1"/>
+          </p:cNvSpPr>
+          <p:nvPr>
+            <p:ph type="body" idx="1"/>
+          </p:nvPr>
+        </p:nvSpPr>
+        <p:spPr/>
+        <p:txBody>
+          <a:bodyPr/>
+          <a:lstStyle/>
+          <a:p>
+            <a:r>
+              <a:rPr lang="en-US" dirty="0"/>
+              <a:t/>
+            </a:r>
+            <a:endParaRPr lang="en-US" dirty="0"/>
+          </a:p>
+        </p:txBody>
+      </p:sp>
+      <p:sp>
+        <p:nvSpPr>
+          <p:cNvPr id="4" name="Slide Number Placeholder 3"/>
+          <p:cNvSpPr>
+            <a:spLocks noGrp="1"/>
+          </p:cNvSpPr>
+          <p:nvPr>
+            <p:ph type="sldNum" sz="quarter" idx="10"/>
+          </p:nvPr>
+        </p:nvSpPr>
+        <p:spPr/>
+        <p:txBody>
+          <a:bodyPr/>
+          <a:lstStyle/>
+          <a:p>
+            <a:fld id="{F7021451-1387-4CA6-816F-3879F97B5CBC}" type="slidenum">
+              <a:rPr lang="en-US"/>
+              <a:t>8</a:t>
             </a:fld>
             <a:endParaRPr lang="en-US"/>
           </a:p>
@@ -8747,6 +8836,598 @@
     <p:bg>
       <p:bgPr>
         <a:solidFill>
+          <a:srgbClr val="FFFFFF"/>
+        </a:solidFill>
+      </p:bgPr>
+    </p:bg>
+    <p:spTree>
+      <p:nvGrpSpPr>
+        <p:cNvPr id="1" name=""/>
+        <p:cNvGrpSpPr/>
+        <p:nvPr/>
+      </p:nvGrpSpPr>
+      <p:grpSpPr>
+        <a:xfrm>
+          <a:off x="0" y="0"/>
+          <a:ext cx="0" cy="0"/>
+          <a:chOff x="0" y="0"/>
+          <a:chExt cx="0" cy="0"/>
+        </a:xfrm>
+      </p:grpSpPr>
+      <p:sp>
+        <p:nvSpPr>
+          <p:cNvPr id="2" name="Text 0"/>
+          <p:cNvSpPr txBox="1"/>
+          <p:nvPr/>
+        </p:nvSpPr>
+        <p:spPr>
+          <a:xfrm>
+            <a:off x="548640" y="365760"/>
+            <a:ext cx="11064240" cy="731520"/>
+          </a:xfrm>
+          <a:prstGeom prst="rect">
+            <a:avLst/>
+          </a:prstGeom>
+          <a:noFill/>
+          <a:ln/>
+        </p:spPr>
+        <p:txBody>
+          <a:bodyPr wrap="square" lIns="0" tIns="0" rIns="0" bIns="0" rtlCol="0" anchor="ctr"/>
+          <a:lstStyle/>
+          <a:p>
+            <a:pPr indent="0" marL="0">
+              <a:buNone/>
+            </a:pPr>
+            <a:r>
+              <a:rPr lang="en-US" sz="3600" b="1" dirty="0">
+                <a:solidFill>
+                  <a:srgbClr val="3B2A5C"/>
+                </a:solidFill>
+                <a:latin typeface="Cambria" pitchFamily="34" charset="0"/>
+                <a:ea typeface="Cambria" pitchFamily="34" charset="-122"/>
+                <a:cs typeface="Cambria" pitchFamily="34" charset="-120"/>
+              </a:rPr>
+              <a:t>Do dan Don'ts display dan penjualan</a:t>
+            </a:r>
+            <a:endParaRPr lang="en-US" sz="3600" dirty="0"/>
+          </a:p>
+        </p:txBody>
+      </p:sp>
+      <p:sp>
+        <p:nvSpPr>
+          <p:cNvPr id="3" name="Text 1"/>
+          <p:cNvSpPr txBox="1"/>
+          <p:nvPr/>
+        </p:nvSpPr>
+        <p:spPr>
+          <a:xfrm>
+            <a:off x="548640" y="1051560"/>
+            <a:ext cx="11064240" cy="365760"/>
+          </a:xfrm>
+          <a:prstGeom prst="rect">
+            <a:avLst/>
+          </a:prstGeom>
+          <a:noFill/>
+          <a:ln/>
+        </p:spPr>
+        <p:txBody>
+          <a:bodyPr wrap="square" lIns="0" tIns="0" rIns="0" bIns="0" rtlCol="0" anchor="ctr"/>
+          <a:lstStyle/>
+          <a:p>
+            <a:pPr indent="0" marL="0">
+              <a:buNone/>
+            </a:pPr>
+            <a:r>
+              <a:rPr lang="en-US" sz="1600" dirty="0">
+                <a:solidFill>
+                  <a:srgbClr val="6B6580"/>
+                </a:solidFill>
+                <a:latin typeface="Calibri" pitchFamily="34" charset="0"/>
+                <a:ea typeface="Calibri" pitchFamily="34" charset="-122"/>
+                <a:cs typeface="Calibri" pitchFamily="34" charset="-120"/>
+              </a:rPr>
+              <a:t>Rekomendasi untuk tim store</a:t>
+            </a:r>
+            <a:endParaRPr lang="en-US" sz="1600" dirty="0"/>
+          </a:p>
+        </p:txBody>
+      </p:sp>
+      <p:sp>
+        <p:nvSpPr>
+          <p:cNvPr id="4" name="Shape 2"/>
+          <p:cNvSpPr/>
+          <p:nvPr/>
+        </p:nvSpPr>
+        <p:spPr>
+          <a:xfrm>
+            <a:off x="548640" y="1645920"/>
+            <a:ext cx="5349240" cy="4754880"/>
+          </a:xfrm>
+          <a:prstGeom prst="roundRect">
+            <a:avLst>
+              <a:gd name="adj" fmla="val 2885"/>
+            </a:avLst>
+          </a:prstGeom>
+          <a:solidFill>
+            <a:srgbClr val="E3F6FB"/>
+          </a:solidFill>
+          <a:ln w="12700">
+            <a:solidFill>
+              <a:srgbClr val="E3F6FB"/>
+            </a:solidFill>
+            <a:prstDash val="solid"/>
+          </a:ln>
+        </p:spPr>
+      </p:sp>
+      <p:sp>
+        <p:nvSpPr>
+          <p:cNvPr id="5" name="Shape 3"/>
+          <p:cNvSpPr/>
+          <p:nvPr/>
+        </p:nvSpPr>
+        <p:spPr>
+          <a:xfrm>
+            <a:off x="822960" y="1828800"/>
+            <a:ext cx="1371600" cy="457200"/>
+          </a:xfrm>
+          <a:prstGeom prst="roundRect">
+            <a:avLst>
+              <a:gd name="adj" fmla="val 50000"/>
+            </a:avLst>
+          </a:prstGeom>
+          <a:solidFill>
+            <a:srgbClr val="4DC3E0"/>
+          </a:solidFill>
+          <a:ln w="12700">
+            <a:solidFill>
+              <a:srgbClr val="4DC3E0"/>
+            </a:solidFill>
+            <a:prstDash val="solid"/>
+          </a:ln>
+        </p:spPr>
+      </p:sp>
+      <p:sp>
+        <p:nvSpPr>
+          <p:cNvPr id="6" name="Text 4"/>
+          <p:cNvSpPr txBox="1"/>
+          <p:nvPr/>
+        </p:nvSpPr>
+        <p:spPr>
+          <a:xfrm>
+            <a:off x="822960" y="1828800"/>
+            <a:ext cx="1371600" cy="457200"/>
+          </a:xfrm>
+          <a:prstGeom prst="rect">
+            <a:avLst/>
+          </a:prstGeom>
+          <a:noFill/>
+          <a:ln/>
+        </p:spPr>
+        <p:txBody>
+          <a:bodyPr wrap="square" lIns="0" tIns="0" rIns="0" bIns="0" rtlCol="0" anchor="ctr"/>
+          <a:lstStyle/>
+          <a:p>
+            <a:pPr algn="ctr" indent="0" marL="0">
+              <a:buNone/>
+            </a:pPr>
+            <a:r>
+              <a:rPr lang="en-US" sz="1800" b="1" dirty="0">
+                <a:solidFill>
+                  <a:srgbClr val="FFFFFF"/>
+                </a:solidFill>
+                <a:latin typeface="Calibri" pitchFamily="34" charset="0"/>
+                <a:ea typeface="Calibri" pitchFamily="34" charset="-122"/>
+                <a:cs typeface="Calibri" pitchFamily="34" charset="-120"/>
+              </a:rPr>
+              <a:t>DO</a:t>
+            </a:r>
+            <a:endParaRPr lang="en-US" sz="1800" dirty="0"/>
+          </a:p>
+        </p:txBody>
+      </p:sp>
+      <p:sp>
+        <p:nvSpPr>
+          <p:cNvPr id="7" name="Text 5"/>
+          <p:cNvSpPr txBox="1"/>
+          <p:nvPr/>
+        </p:nvSpPr>
+        <p:spPr>
+          <a:xfrm>
+            <a:off x="822960" y="2514600"/>
+            <a:ext cx="4800600" cy="3749040"/>
+          </a:xfrm>
+          <a:prstGeom prst="rect">
+            <a:avLst/>
+          </a:prstGeom>
+          <a:noFill/>
+          <a:ln/>
+        </p:spPr>
+        <p:txBody>
+          <a:bodyPr wrap="square" lIns="0" tIns="0" rIns="0" bIns="0" rtlCol="0" anchor="t"/>
+          <a:lstStyle/>
+          <a:p>
+            <a:pPr marL="342900" indent="-342900">
+              <a:spcAft>
+                <a:spcPts val="1200"/>
+              </a:spcAft>
+              <a:buSzPct val="100000"/>
+              <a:buChar char="•"/>
+            </a:pPr>
+            <a:r>
+              <a:rPr lang="en-US" sz="1800" dirty="0">
+                <a:solidFill>
+                  <a:srgbClr val="3B2A5C"/>
+                </a:solidFill>
+                <a:latin typeface="Calibri" pitchFamily="34" charset="0"/>
+                <a:ea typeface="Calibri" pitchFamily="34" charset="-122"/>
+                <a:cs typeface="Calibri" pitchFamily="34" charset="-120"/>
+              </a:rPr>
+              <a:t>Pasang di Endcap Area Thermal, full terisi sesuai planogram dan mock</a:t>
+            </a:r>
+            <a:endParaRPr lang="en-US" sz="1800" dirty="0"/>
+          </a:p>
+          <a:p>
+            <a:pPr marL="342900" indent="-342900">
+              <a:spcAft>
+                <a:spcPts val="1200"/>
+              </a:spcAft>
+              <a:buSzPct val="100000"/>
+              <a:buChar char="•"/>
+            </a:pPr>
+            <a:r>
+              <a:rPr lang="en-US" sz="1800" dirty="0">
+                <a:solidFill>
+                  <a:srgbClr val="3B2A5C"/>
+                </a:solidFill>
+                <a:latin typeface="Calibri" pitchFamily="34" charset="0"/>
+                <a:ea typeface="Calibri" pitchFamily="34" charset="-122"/>
+                <a:cs typeface="Calibri" pitchFamily="34" charset="-120"/>
+              </a:rPr>
+              <a:t>Buka hanya 6 warna sebagai sampel, sisanya tetap tersegel</a:t>
+            </a:r>
+            <a:endParaRPr lang="en-US" sz="1800" dirty="0"/>
+          </a:p>
+          <a:p>
+            <a:pPr marL="342900" indent="-342900">
+              <a:spcAft>
+                <a:spcPts val="1200"/>
+              </a:spcAft>
+              <a:buSzPct val="100000"/>
+              <a:buChar char="•"/>
+            </a:pPr>
+            <a:r>
+              <a:rPr lang="en-US" sz="1800" dirty="0">
+                <a:solidFill>
+                  <a:srgbClr val="3B2A5C"/>
+                </a:solidFill>
+                <a:latin typeface="Calibri" pitchFamily="34" charset="0"/>
+                <a:ea typeface="Calibri" pitchFamily="34" charset="-122"/>
+                <a:cs typeface="Calibri" pitchFamily="34" charset="-120"/>
+              </a:rPr>
+              <a:t>Jaga box Secret tetap tersegel</a:t>
+            </a:r>
+            <a:endParaRPr lang="en-US" sz="1800" dirty="0"/>
+          </a:p>
+          <a:p>
+            <a:pPr marL="342900" indent="-342900">
+              <a:spcAft>
+                <a:spcPts val="1200"/>
+              </a:spcAft>
+              <a:buSzPct val="100000"/>
+              <a:buChar char="•"/>
+            </a:pPr>
+            <a:r>
+              <a:rPr lang="en-US" sz="1800" dirty="0">
+                <a:solidFill>
+                  <a:srgbClr val="3B2A5C"/>
+                </a:solidFill>
+                <a:latin typeface="Calibri" pitchFamily="34" charset="0"/>
+                <a:ea typeface="Calibri" pitchFamily="34" charset="-122"/>
+                <a:cs typeface="Calibri" pitchFamily="34" charset="-120"/>
+              </a:rPr>
+              <a:t>Rapikan box, logo informa menghadap depan</a:t>
+            </a:r>
+            <a:endParaRPr lang="en-US" sz="1800" dirty="0"/>
+          </a:p>
+          <a:p>
+            <a:pPr marL="342900" indent="-342900">
+              <a:spcAft>
+                <a:spcPts val="1200"/>
+              </a:spcAft>
+              <a:buSzPct val="100000"/>
+              <a:buChar char="•"/>
+            </a:pPr>
+            <a:r>
+              <a:rPr lang="en-US" sz="1800" dirty="0">
+                <a:solidFill>
+                  <a:srgbClr val="3B2A5C"/>
+                </a:solidFill>
+                <a:latin typeface="Calibri" pitchFamily="34" charset="0"/>
+                <a:ea typeface="Calibri" pitchFamily="34" charset="-122"/>
+                <a:cs typeface="Calibri" pitchFamily="34" charset="-120"/>
+              </a:rPr>
+              <a:t>Isi ulang rak dari buffer stock sebelum kosong</a:t>
+            </a:r>
+            <a:endParaRPr lang="en-US" sz="1800" dirty="0"/>
+          </a:p>
+          <a:p>
+            <a:pPr marL="342900" indent="-342900">
+              <a:spcAft>
+                <a:spcPts val="1200"/>
+              </a:spcAft>
+              <a:buSzPct val="100000"/>
+              <a:buChar char="•"/>
+            </a:pPr>
+            <a:r>
+              <a:rPr lang="en-US" sz="1800" dirty="0">
+                <a:solidFill>
+                  <a:srgbClr val="3B2A5C"/>
+                </a:solidFill>
+                <a:latin typeface="Calibri" pitchFamily="34" charset="0"/>
+                <a:ea typeface="Calibri" pitchFamily="34" charset="-122"/>
+                <a:cs typeface="Calibri" pitchFamily="34" charset="-120"/>
+              </a:rPr>
+              <a:t>Jelaskan ke pelanggan: pilih warna favorit, Secret adalah kejutan</a:t>
+            </a:r>
+            <a:endParaRPr lang="en-US" sz="1800" dirty="0"/>
+          </a:p>
+        </p:txBody>
+      </p:sp>
+      <p:sp>
+        <p:nvSpPr>
+          <p:cNvPr id="8" name="Shape 6"/>
+          <p:cNvSpPr/>
+          <p:nvPr/>
+        </p:nvSpPr>
+        <p:spPr>
+          <a:xfrm>
+            <a:off x="6263640" y="1645920"/>
+            <a:ext cx="5349240" cy="4754880"/>
+          </a:xfrm>
+          <a:prstGeom prst="roundRect">
+            <a:avLst>
+              <a:gd name="adj" fmla="val 2885"/>
+            </a:avLst>
+          </a:prstGeom>
+          <a:solidFill>
+            <a:srgbClr val="FDEAF3"/>
+          </a:solidFill>
+          <a:ln w="12700">
+            <a:solidFill>
+              <a:srgbClr val="FDEAF3"/>
+            </a:solidFill>
+            <a:prstDash val="solid"/>
+          </a:ln>
+        </p:spPr>
+      </p:sp>
+      <p:sp>
+        <p:nvSpPr>
+          <p:cNvPr id="9" name="Shape 7"/>
+          <p:cNvSpPr/>
+          <p:nvPr/>
+        </p:nvSpPr>
+        <p:spPr>
+          <a:xfrm>
+            <a:off x="6537960" y="1828800"/>
+            <a:ext cx="1371600" cy="457200"/>
+          </a:xfrm>
+          <a:prstGeom prst="roundRect">
+            <a:avLst>
+              <a:gd name="adj" fmla="val 50000"/>
+            </a:avLst>
+          </a:prstGeom>
+          <a:solidFill>
+            <a:srgbClr val="F27BB0"/>
+          </a:solidFill>
+          <a:ln w="12700">
+            <a:solidFill>
+              <a:srgbClr val="F27BB0"/>
+            </a:solidFill>
+            <a:prstDash val="solid"/>
+          </a:ln>
+        </p:spPr>
+      </p:sp>
+      <p:sp>
+        <p:nvSpPr>
+          <p:cNvPr id="10" name="Text 8"/>
+          <p:cNvSpPr txBox="1"/>
+          <p:nvPr/>
+        </p:nvSpPr>
+        <p:spPr>
+          <a:xfrm>
+            <a:off x="6537960" y="1828800"/>
+            <a:ext cx="1371600" cy="457200"/>
+          </a:xfrm>
+          <a:prstGeom prst="rect">
+            <a:avLst/>
+          </a:prstGeom>
+          <a:noFill/>
+          <a:ln/>
+        </p:spPr>
+        <p:txBody>
+          <a:bodyPr wrap="square" lIns="0" tIns="0" rIns="0" bIns="0" rtlCol="0" anchor="ctr"/>
+          <a:lstStyle/>
+          <a:p>
+            <a:pPr algn="ctr" indent="0" marL="0">
+              <a:buNone/>
+            </a:pPr>
+            <a:r>
+              <a:rPr lang="en-US" sz="1800" b="1" dirty="0">
+                <a:solidFill>
+                  <a:srgbClr val="FFFFFF"/>
+                </a:solidFill>
+                <a:latin typeface="Calibri" pitchFamily="34" charset="0"/>
+                <a:ea typeface="Calibri" pitchFamily="34" charset="-122"/>
+                <a:cs typeface="Calibri" pitchFamily="34" charset="-120"/>
+              </a:rPr>
+              <a:t>DON'T</a:t>
+            </a:r>
+            <a:endParaRPr lang="en-US" sz="1800" dirty="0"/>
+          </a:p>
+        </p:txBody>
+      </p:sp>
+      <p:sp>
+        <p:nvSpPr>
+          <p:cNvPr id="11" name="Text 9"/>
+          <p:cNvSpPr txBox="1"/>
+          <p:nvPr/>
+        </p:nvSpPr>
+        <p:spPr>
+          <a:xfrm>
+            <a:off x="6537960" y="2514600"/>
+            <a:ext cx="4800600" cy="3749040"/>
+          </a:xfrm>
+          <a:prstGeom prst="rect">
+            <a:avLst/>
+          </a:prstGeom>
+          <a:noFill/>
+          <a:ln/>
+        </p:spPr>
+        <p:txBody>
+          <a:bodyPr wrap="square" lIns="0" tIns="0" rIns="0" bIns="0" rtlCol="0" anchor="t"/>
+          <a:lstStyle/>
+          <a:p>
+            <a:pPr marL="342900" indent="-342900">
+              <a:spcAft>
+                <a:spcPts val="1200"/>
+              </a:spcAft>
+              <a:buSzPct val="100000"/>
+              <a:buChar char="•"/>
+            </a:pPr>
+            <a:r>
+              <a:rPr lang="en-US" sz="1800" dirty="0">
+                <a:solidFill>
+                  <a:srgbClr val="3B2A5C"/>
+                </a:solidFill>
+                <a:latin typeface="Calibri" pitchFamily="34" charset="0"/>
+                <a:ea typeface="Calibri" pitchFamily="34" charset="-122"/>
+                <a:cs typeface="Calibri" pitchFamily="34" charset="-120"/>
+              </a:rPr>
+              <a:t>Jangan taruh di luar endcap Thermal atau campur dengan produk lain</a:t>
+            </a:r>
+            <a:endParaRPr lang="en-US" sz="1800" dirty="0"/>
+          </a:p>
+          <a:p>
+            <a:pPr marL="342900" indent="-342900">
+              <a:spcAft>
+                <a:spcPts val="1200"/>
+              </a:spcAft>
+              <a:buSzPct val="100000"/>
+              <a:buChar char="•"/>
+            </a:pPr>
+            <a:r>
+              <a:rPr lang="en-US" sz="1800" dirty="0">
+                <a:solidFill>
+                  <a:srgbClr val="3B2A5C"/>
+                </a:solidFill>
+                <a:latin typeface="Calibri" pitchFamily="34" charset="0"/>
+                <a:ea typeface="Calibri" pitchFamily="34" charset="-122"/>
+                <a:cs typeface="Calibri" pitchFamily="34" charset="-120"/>
+              </a:rPr>
+              <a:t>Jangan biarkan rak kosong atau terisi sebagian</a:t>
+            </a:r>
+            <a:endParaRPr lang="en-US" sz="1800" dirty="0"/>
+          </a:p>
+          <a:p>
+            <a:pPr marL="342900" indent="-342900">
+              <a:spcAft>
+                <a:spcPts val="1200"/>
+              </a:spcAft>
+              <a:buSzPct val="100000"/>
+              <a:buChar char="•"/>
+            </a:pPr>
+            <a:r>
+              <a:rPr lang="en-US" sz="1800" dirty="0">
+                <a:solidFill>
+                  <a:srgbClr val="3B2A5C"/>
+                </a:solidFill>
+                <a:latin typeface="Calibri" pitchFamily="34" charset="0"/>
+                <a:ea typeface="Calibri" pitchFamily="34" charset="-122"/>
+                <a:cs typeface="Calibri" pitchFamily="34" charset="-120"/>
+              </a:rPr>
+              <a:t>Jangan buka atau sobek box selain sampel 6 warna</a:t>
+            </a:r>
+            <a:endParaRPr lang="en-US" sz="1800" dirty="0"/>
+          </a:p>
+          <a:p>
+            <a:pPr marL="342900" indent="-342900">
+              <a:spcAft>
+                <a:spcPts val="1200"/>
+              </a:spcAft>
+              <a:buSzPct val="100000"/>
+              <a:buChar char="•"/>
+            </a:pPr>
+            <a:r>
+              <a:rPr lang="en-US" sz="1800" dirty="0">
+                <a:solidFill>
+                  <a:srgbClr val="3B2A5C"/>
+                </a:solidFill>
+                <a:latin typeface="Calibri" pitchFamily="34" charset="0"/>
+                <a:ea typeface="Calibri" pitchFamily="34" charset="-122"/>
+                <a:cs typeface="Calibri" pitchFamily="34" charset="-120"/>
+              </a:rPr>
+              <a:t>Jangan bocorkan isi box tersegel (ditimbang, diguncang, atau diberi petunjuk)</a:t>
+            </a:r>
+            <a:endParaRPr lang="en-US" sz="1800" dirty="0"/>
+          </a:p>
+          <a:p>
+            <a:pPr marL="342900" indent="-342900">
+              <a:spcAft>
+                <a:spcPts val="1200"/>
+              </a:spcAft>
+              <a:buSzPct val="100000"/>
+              <a:buChar char="•"/>
+            </a:pPr>
+            <a:r>
+              <a:rPr lang="en-US" sz="1800" dirty="0">
+                <a:solidFill>
+                  <a:srgbClr val="3B2A5C"/>
+                </a:solidFill>
+                <a:latin typeface="Calibri" pitchFamily="34" charset="0"/>
+                <a:ea typeface="Calibri" pitchFamily="34" charset="-122"/>
+                <a:cs typeface="Calibri" pitchFamily="34" charset="-120"/>
+              </a:rPr>
+              <a:t>Jangan ubah susunan, qty, atau tinggi rak</a:t>
+            </a:r>
+            <a:endParaRPr lang="en-US" sz="1800" dirty="0"/>
+          </a:p>
+          <a:p>
+            <a:pPr marL="342900" indent="-342900">
+              <a:spcAft>
+                <a:spcPts val="1200"/>
+              </a:spcAft>
+              <a:buSzPct val="100000"/>
+              <a:buChar char="•"/>
+            </a:pPr>
+            <a:r>
+              <a:rPr lang="en-US" sz="1800" dirty="0">
+                <a:solidFill>
+                  <a:srgbClr val="3B2A5C"/>
+                </a:solidFill>
+                <a:latin typeface="Calibri" pitchFamily="34" charset="0"/>
+                <a:ea typeface="Calibri" pitchFamily="34" charset="-122"/>
+                <a:cs typeface="Calibri" pitchFamily="34" charset="-120"/>
+              </a:rPr>
+              <a:t>Jangan jual unit sampel yang sudah dibuka sebagai produk baru</a:t>
+            </a:r>
+            <a:endParaRPr lang="en-US" sz="1800" dirty="0"/>
+          </a:p>
+        </p:txBody>
+      </p:sp>
+    </p:spTree>
+  </p:cSld>
+  <p:clrMapOvr>
+    <a:masterClrMapping/>
+  </p:clrMapOvr>
+</p:sld>
+</file>
+
+<file path=ppt/slides/slide8.xml><?xml version="1.0" encoding="utf-8"?>
+<p:sld xmlns:a="http://schemas.openxmlformats.org/drawingml/2006/main" xmlns:r="http://schemas.openxmlformats.org/officeDocument/2006/relationships" xmlns:p="http://schemas.openxmlformats.org/presentationml/2006/main">
+  <p:cSld name="Slide 8">
+    <p:bg>
+      <p:bgPr>
+        <a:solidFill>
           <a:srgbClr val="3B2A5C"/>
         </a:solidFill>
       </p:bgPr>

</xml_diff>

<commit_message>
Revise deck: 3D header, VM header info, temporary POP rule, summary checklist
Co-Authored-By: Claude Sonnet 5.5 <noreply@anthropic.com>
Claude-Session: https://claude.ai/code/session_01WvUriRkWqtmHorCL8uL8C7
</commit_message>
<xml_diff>
--- a/Instruksi_Display_Blind_Box_Thermal.pptx
+++ b/Instruksi_Display_Blind_Box_Thermal.pptx
@@ -1966,7 +1966,7 @@
         </p:nvSpPr>
         <p:spPr>
           <a:xfrm>
-            <a:off x="548640" y="457200"/>
+            <a:off x="548640" y="365760"/>
             <a:ext cx="10972800" cy="731520"/>
           </a:xfrm>
           <a:prstGeom prst="rect">
@@ -1991,7 +1991,7 @@
                 <a:ea typeface="Cambria" pitchFamily="34" charset="-122"/>
                 <a:cs typeface="Cambria" pitchFamily="34" charset="-120"/>
               </a:rPr>
-              <a:t>Checklist sebelum lapor selesai</a:t>
+              <a:t>Summary check list tim store</a:t>
             </a:r>
             <a:endParaRPr lang="en-US" sz="3600" dirty="0"/>
           </a:p>
@@ -2005,12 +2005,12 @@
         </p:nvSpPr>
         <p:spPr>
           <a:xfrm>
-            <a:off x="548640" y="1554480"/>
-            <a:ext cx="11064240" cy="621792"/>
+            <a:off x="548640" y="1325880"/>
+            <a:ext cx="11064240" cy="548640"/>
           </a:xfrm>
           <a:prstGeom prst="roundRect">
             <a:avLst>
-              <a:gd name="adj" fmla="val 17647"/>
+              <a:gd name="adj" fmla="val 20000"/>
             </a:avLst>
           </a:prstGeom>
           <a:solidFill>
@@ -2032,7 +2032,7 @@
         </p:nvSpPr>
         <p:spPr>
           <a:xfrm>
-            <a:off x="731520" y="1682496"/>
+            <a:off x="731520" y="1417320"/>
             <a:ext cx="365760" cy="365760"/>
           </a:xfrm>
           <a:prstGeom prst="ellipse">
@@ -2057,7 +2057,7 @@
         </p:nvSpPr>
         <p:spPr>
           <a:xfrm>
-            <a:off x="731520" y="1682496"/>
+            <a:off x="731520" y="1417320"/>
             <a:ext cx="365760" cy="365760"/>
           </a:xfrm>
           <a:prstGeom prst="rect">
@@ -2096,8 +2096,8 @@
         </p:nvSpPr>
         <p:spPr>
           <a:xfrm>
-            <a:off x="1325880" y="1554480"/>
-            <a:ext cx="10058400" cy="621792"/>
+            <a:off x="1325880" y="1325880"/>
+            <a:ext cx="10149840" cy="548640"/>
           </a:xfrm>
           <a:prstGeom prst="rect">
             <a:avLst/>
@@ -2113,7 +2113,7 @@
               <a:buNone/>
             </a:pPr>
             <a:r>
-              <a:rPr lang="en-US" sz="1800" dirty="0">
+              <a:rPr lang="en-US" sz="1600" dirty="0">
                 <a:solidFill>
                   <a:srgbClr val="FFFFFF"/>
                 </a:solidFill>
@@ -2121,9 +2121,9 @@
                 <a:ea typeface="Calibri" pitchFamily="34" charset="-122"/>
                 <a:cs typeface="Calibri" pitchFamily="34" charset="-120"/>
               </a:rPr>
-              <a:t>Display di Endcap Area Thermal</a:t>
+              <a:t>Display di Endcap Area Thermal, full terisi Blind Box</a:t>
             </a:r>
-            <a:endParaRPr lang="en-US" sz="1800" dirty="0"/>
+            <a:endParaRPr lang="en-US" sz="1600" dirty="0"/>
           </a:p>
         </p:txBody>
       </p:sp>
@@ -2135,12 +2135,12 @@
         </p:nvSpPr>
         <p:spPr>
           <a:xfrm>
-            <a:off x="548640" y="2304288"/>
-            <a:ext cx="11064240" cy="621792"/>
+            <a:off x="548640" y="1984248"/>
+            <a:ext cx="11064240" cy="548640"/>
           </a:xfrm>
           <a:prstGeom prst="roundRect">
             <a:avLst>
-              <a:gd name="adj" fmla="val 17647"/>
+              <a:gd name="adj" fmla="val 20000"/>
             </a:avLst>
           </a:prstGeom>
           <a:solidFill>
@@ -2162,7 +2162,7 @@
         </p:nvSpPr>
         <p:spPr>
           <a:xfrm>
-            <a:off x="731520" y="2432304"/>
+            <a:off x="731520" y="2075688"/>
             <a:ext cx="365760" cy="365760"/>
           </a:xfrm>
           <a:prstGeom prst="ellipse">
@@ -2187,7 +2187,7 @@
         </p:nvSpPr>
         <p:spPr>
           <a:xfrm>
-            <a:off x="731520" y="2432304"/>
+            <a:off x="731520" y="2075688"/>
             <a:ext cx="365760" cy="365760"/>
           </a:xfrm>
           <a:prstGeom prst="rect">
@@ -2226,8 +2226,8 @@
         </p:nvSpPr>
         <p:spPr>
           <a:xfrm>
-            <a:off x="1325880" y="2304288"/>
-            <a:ext cx="10058400" cy="621792"/>
+            <a:off x="1325880" y="1984248"/>
+            <a:ext cx="10149840" cy="548640"/>
           </a:xfrm>
           <a:prstGeom prst="rect">
             <a:avLst/>
@@ -2243,7 +2243,7 @@
               <a:buNone/>
             </a:pPr>
             <a:r>
-              <a:rPr lang="en-US" sz="1800" dirty="0">
+              <a:rPr lang="en-US" sz="1600" dirty="0">
                 <a:solidFill>
                   <a:srgbClr val="FFFFFF"/>
                 </a:solidFill>
@@ -2251,9 +2251,9 @@
                 <a:ea typeface="Calibri" pitchFamily="34" charset="-122"/>
                 <a:cs typeface="Calibri" pitchFamily="34" charset="-120"/>
               </a:rPr>
-              <a:t>Endcap full terisi Blind Box, tidak ada rak kosong</a:t>
+              <a:t>Qty sesuai alokasi: Dept + Kasir (120 SMALL, 96 LARGE), Dept only (96 SMALL, 72 LARGE)</a:t>
             </a:r>
-            <a:endParaRPr lang="en-US" sz="1800" dirty="0"/>
+            <a:endParaRPr lang="en-US" sz="1600" dirty="0"/>
           </a:p>
         </p:txBody>
       </p:sp>
@@ -2265,12 +2265,12 @@
         </p:nvSpPr>
         <p:spPr>
           <a:xfrm>
-            <a:off x="548640" y="3054096"/>
-            <a:ext cx="11064240" cy="621792"/>
+            <a:off x="548640" y="2642616"/>
+            <a:ext cx="11064240" cy="548640"/>
           </a:xfrm>
           <a:prstGeom prst="roundRect">
             <a:avLst>
-              <a:gd name="adj" fmla="val 17647"/>
+              <a:gd name="adj" fmla="val 20000"/>
             </a:avLst>
           </a:prstGeom>
           <a:solidFill>
@@ -2292,7 +2292,7 @@
         </p:nvSpPr>
         <p:spPr>
           <a:xfrm>
-            <a:off x="731520" y="3182112"/>
+            <a:off x="731520" y="2734056"/>
             <a:ext cx="365760" cy="365760"/>
           </a:xfrm>
           <a:prstGeom prst="ellipse">
@@ -2317,7 +2317,7 @@
         </p:nvSpPr>
         <p:spPr>
           <a:xfrm>
-            <a:off x="731520" y="3182112"/>
+            <a:off x="731520" y="2734056"/>
             <a:ext cx="365760" cy="365760"/>
           </a:xfrm>
           <a:prstGeom prst="rect">
@@ -2356,8 +2356,8 @@
         </p:nvSpPr>
         <p:spPr>
           <a:xfrm>
-            <a:off x="1325880" y="3054096"/>
-            <a:ext cx="10058400" cy="621792"/>
+            <a:off x="1325880" y="2642616"/>
+            <a:ext cx="10149840" cy="548640"/>
           </a:xfrm>
           <a:prstGeom prst="rect">
             <a:avLst/>
@@ -2373,7 +2373,7 @@
               <a:buNone/>
             </a:pPr>
             <a:r>
-              <a:rPr lang="en-US" sz="1800" dirty="0">
+              <a:rPr lang="en-US" sz="1600" dirty="0">
                 <a:solidFill>
                   <a:srgbClr val="FFFFFF"/>
                 </a:solidFill>
@@ -2381,9 +2381,9 @@
                 <a:ea typeface="Calibri" pitchFamily="34" charset="-122"/>
                 <a:cs typeface="Calibri" pitchFamily="34" charset="-120"/>
               </a:rPr>
-              <a:t>Qty tiap rak sesuai planogram (16 box SMALL, 12 box LARGE)</a:t>
+              <a:t>Susunan rak sesuai planogram dan mock (16 box SMALL, 12 box LARGE)</a:t>
             </a:r>
-            <a:endParaRPr lang="en-US" sz="1800" dirty="0"/>
+            <a:endParaRPr lang="en-US" sz="1600" dirty="0"/>
           </a:p>
         </p:txBody>
       </p:sp>
@@ -2395,12 +2395,12 @@
         </p:nvSpPr>
         <p:spPr>
           <a:xfrm>
-            <a:off x="548640" y="3803904"/>
-            <a:ext cx="11064240" cy="621792"/>
+            <a:off x="548640" y="3300984"/>
+            <a:ext cx="11064240" cy="548640"/>
           </a:xfrm>
           <a:prstGeom prst="roundRect">
             <a:avLst>
-              <a:gd name="adj" fmla="val 17647"/>
+              <a:gd name="adj" fmla="val 20000"/>
             </a:avLst>
           </a:prstGeom>
           <a:solidFill>
@@ -2422,7 +2422,7 @@
         </p:nvSpPr>
         <p:spPr>
           <a:xfrm>
-            <a:off x="731520" y="3931920"/>
+            <a:off x="731520" y="3392424"/>
             <a:ext cx="365760" cy="365760"/>
           </a:xfrm>
           <a:prstGeom prst="ellipse">
@@ -2447,7 +2447,7 @@
         </p:nvSpPr>
         <p:spPr>
           <a:xfrm>
-            <a:off x="731520" y="3931920"/>
+            <a:off x="731520" y="3392424"/>
             <a:ext cx="365760" cy="365760"/>
           </a:xfrm>
           <a:prstGeom prst="rect">
@@ -2486,8 +2486,8 @@
         </p:nvSpPr>
         <p:spPr>
           <a:xfrm>
-            <a:off x="1325880" y="3803904"/>
-            <a:ext cx="10058400" cy="621792"/>
+            <a:off x="1325880" y="3300984"/>
+            <a:ext cx="10149840" cy="548640"/>
           </a:xfrm>
           <a:prstGeom prst="rect">
             <a:avLst/>
@@ -2503,7 +2503,7 @@
               <a:buNone/>
             </a:pPr>
             <a:r>
-              <a:rPr lang="en-US" sz="1800" dirty="0">
+              <a:rPr lang="en-US" sz="1600" dirty="0">
                 <a:solidFill>
                   <a:srgbClr val="FFFFFF"/>
                 </a:solidFill>
@@ -2511,9 +2511,9 @@
                 <a:ea typeface="Calibri" pitchFamily="34" charset="-122"/>
                 <a:cs typeface="Calibri" pitchFamily="34" charset="-120"/>
               </a:rPr>
-              <a:t>Susunan sesuai mock display</a:t>
+              <a:t>6 warna dibuka sebagai sampel, Secret tetap tersegel</a:t>
             </a:r>
-            <a:endParaRPr lang="en-US" sz="1800" dirty="0"/>
+            <a:endParaRPr lang="en-US" sz="1600" dirty="0"/>
           </a:p>
         </p:txBody>
       </p:sp>
@@ -2525,12 +2525,12 @@
         </p:nvSpPr>
         <p:spPr>
           <a:xfrm>
-            <a:off x="548640" y="4553712"/>
-            <a:ext cx="11064240" cy="621792"/>
+            <a:off x="548640" y="3959352"/>
+            <a:ext cx="11064240" cy="548640"/>
           </a:xfrm>
           <a:prstGeom prst="roundRect">
             <a:avLst>
-              <a:gd name="adj" fmla="val 17647"/>
+              <a:gd name="adj" fmla="val 20000"/>
             </a:avLst>
           </a:prstGeom>
           <a:solidFill>
@@ -2552,7 +2552,7 @@
         </p:nvSpPr>
         <p:spPr>
           <a:xfrm>
-            <a:off x="731520" y="4681728"/>
+            <a:off x="731520" y="4050792"/>
             <a:ext cx="365760" cy="365760"/>
           </a:xfrm>
           <a:prstGeom prst="ellipse">
@@ -2577,7 +2577,7 @@
         </p:nvSpPr>
         <p:spPr>
           <a:xfrm>
-            <a:off x="731520" y="4681728"/>
+            <a:off x="731520" y="4050792"/>
             <a:ext cx="365760" cy="365760"/>
           </a:xfrm>
           <a:prstGeom prst="rect">
@@ -2616,8 +2616,8 @@
         </p:nvSpPr>
         <p:spPr>
           <a:xfrm>
-            <a:off x="1325880" y="4553712"/>
-            <a:ext cx="10058400" cy="621792"/>
+            <a:off x="1325880" y="3959352"/>
+            <a:ext cx="10149840" cy="548640"/>
           </a:xfrm>
           <a:prstGeom prst="rect">
             <a:avLst/>
@@ -2633,7 +2633,7 @@
               <a:buNone/>
             </a:pPr>
             <a:r>
-              <a:rPr lang="en-US" sz="1800" dirty="0">
+              <a:rPr lang="en-US" sz="1600" dirty="0">
                 <a:solidFill>
                   <a:srgbClr val="FFFFFF"/>
                 </a:solidFill>
@@ -2641,9 +2641,9 @@
                 <a:ea typeface="Calibri" pitchFamily="34" charset="-122"/>
                 <a:cs typeface="Calibri" pitchFamily="34" charset="-120"/>
               </a:rPr>
-              <a:t>6 warna terbuka di display, Secret tidak dibuka</a:t>
+              <a:t>Header dari tim VM Jakarta dipasang saat tiba</a:t>
             </a:r>
-            <a:endParaRPr lang="en-US" sz="1800" dirty="0"/>
+            <a:endParaRPr lang="en-US" sz="1600" dirty="0"/>
           </a:p>
         </p:txBody>
       </p:sp>
@@ -2655,12 +2655,12 @@
         </p:nvSpPr>
         <p:spPr>
           <a:xfrm>
-            <a:off x="548640" y="5303520"/>
-            <a:ext cx="11064240" cy="621792"/>
+            <a:off x="548640" y="4617720"/>
+            <a:ext cx="11064240" cy="548640"/>
           </a:xfrm>
           <a:prstGeom prst="roundRect">
             <a:avLst>
-              <a:gd name="adj" fmla="val 17647"/>
+              <a:gd name="adj" fmla="val 20000"/>
             </a:avLst>
           </a:prstGeom>
           <a:solidFill>
@@ -2682,7 +2682,7 @@
         </p:nvSpPr>
         <p:spPr>
           <a:xfrm>
-            <a:off x="731520" y="5431536"/>
+            <a:off x="731520" y="4709160"/>
             <a:ext cx="365760" cy="365760"/>
           </a:xfrm>
           <a:prstGeom prst="ellipse">
@@ -2707,7 +2707,7 @@
         </p:nvSpPr>
         <p:spPr>
           <a:xfrm>
-            <a:off x="731520" y="5431536"/>
+            <a:off x="731520" y="4709160"/>
             <a:ext cx="365760" cy="365760"/>
           </a:xfrm>
           <a:prstGeom prst="rect">
@@ -2746,8 +2746,8 @@
         </p:nvSpPr>
         <p:spPr>
           <a:xfrm>
-            <a:off x="1325880" y="5303520"/>
-            <a:ext cx="10058400" cy="621792"/>
+            <a:off x="1325880" y="4617720"/>
+            <a:ext cx="10149840" cy="548640"/>
           </a:xfrm>
           <a:prstGeom prst="rect">
             <a:avLst/>
@@ -2763,7 +2763,7 @@
               <a:buNone/>
             </a:pPr>
             <a:r>
-              <a:rPr lang="en-US" sz="1800" dirty="0">
+              <a:rPr lang="en-US" sz="1600" dirty="0">
                 <a:solidFill>
                   <a:srgbClr val="FFFFFF"/>
                 </a:solidFill>
@@ -2771,9 +2771,139 @@
                 <a:ea typeface="Calibri" pitchFamily="34" charset="-122"/>
                 <a:cs typeface="Calibri" pitchFamily="34" charset="-120"/>
               </a:rPr>
-              <a:t>POP A4 sudah dicetak dan terpasang</a:t>
+              <a:t>Materi komunikasi belum tiba: cetak POP A4 dari Head Office di percetakan</a:t>
             </a:r>
-            <a:endParaRPr lang="en-US" sz="1800" dirty="0"/>
+            <a:endParaRPr lang="en-US" sz="1600" dirty="0"/>
+          </a:p>
+        </p:txBody>
+      </p:sp>
+      <p:sp>
+        <p:nvSpPr>
+          <p:cNvPr id="27" name="Shape 25"/>
+          <p:cNvSpPr/>
+          <p:nvPr/>
+        </p:nvSpPr>
+        <p:spPr>
+          <a:xfrm>
+            <a:off x="548640" y="5276088"/>
+            <a:ext cx="11064240" cy="548640"/>
+          </a:xfrm>
+          <a:prstGeom prst="roundRect">
+            <a:avLst>
+              <a:gd name="adj" fmla="val 20000"/>
+            </a:avLst>
+          </a:prstGeom>
+          <a:solidFill>
+            <a:srgbClr val="4D3B73"/>
+          </a:solidFill>
+          <a:ln w="12700">
+            <a:solidFill>
+              <a:srgbClr val="4D3B73"/>
+            </a:solidFill>
+            <a:prstDash val="solid"/>
+          </a:ln>
+        </p:spPr>
+      </p:sp>
+      <p:sp>
+        <p:nvSpPr>
+          <p:cNvPr id="28" name="Shape 26"/>
+          <p:cNvSpPr/>
+          <p:nvPr/>
+        </p:nvSpPr>
+        <p:spPr>
+          <a:xfrm>
+            <a:off x="731520" y="5367528"/>
+            <a:ext cx="365760" cy="365760"/>
+          </a:xfrm>
+          <a:prstGeom prst="ellipse">
+            <a:avLst/>
+          </a:prstGeom>
+          <a:solidFill>
+            <a:srgbClr val="FDE68A"/>
+          </a:solidFill>
+          <a:ln w="12700">
+            <a:solidFill>
+              <a:srgbClr val="FDE68A"/>
+            </a:solidFill>
+            <a:prstDash val="solid"/>
+          </a:ln>
+        </p:spPr>
+      </p:sp>
+      <p:sp>
+        <p:nvSpPr>
+          <p:cNvPr id="29" name="Text 27"/>
+          <p:cNvSpPr txBox="1"/>
+          <p:nvPr/>
+        </p:nvSpPr>
+        <p:spPr>
+          <a:xfrm>
+            <a:off x="731520" y="5367528"/>
+            <a:ext cx="365760" cy="365760"/>
+          </a:xfrm>
+          <a:prstGeom prst="rect">
+            <a:avLst/>
+          </a:prstGeom>
+          <a:noFill/>
+          <a:ln/>
+        </p:spPr>
+        <p:txBody>
+          <a:bodyPr wrap="square" lIns="0" tIns="0" rIns="0" bIns="0" rtlCol="0" anchor="ctr"/>
+          <a:lstStyle/>
+          <a:p>
+            <a:pPr algn="ctr" indent="0" marL="0">
+              <a:buNone/>
+            </a:pPr>
+            <a:r>
+              <a:rPr lang="en-US" sz="1600" b="1" dirty="0">
+                <a:solidFill>
+                  <a:srgbClr val="3B2A5C"/>
+                </a:solidFill>
+                <a:latin typeface="Calibri" pitchFamily="34" charset="0"/>
+                <a:ea typeface="Calibri" pitchFamily="34" charset="-122"/>
+                <a:cs typeface="Calibri" pitchFamily="34" charset="-120"/>
+              </a:rPr>
+              <a:t>✓</a:t>
+            </a:r>
+            <a:endParaRPr lang="en-US" sz="1600" dirty="0"/>
+          </a:p>
+        </p:txBody>
+      </p:sp>
+      <p:sp>
+        <p:nvSpPr>
+          <p:cNvPr id="30" name="Text 28"/>
+          <p:cNvSpPr txBox="1"/>
+          <p:nvPr/>
+        </p:nvSpPr>
+        <p:spPr>
+          <a:xfrm>
+            <a:off x="1325880" y="5276088"/>
+            <a:ext cx="10149840" cy="548640"/>
+          </a:xfrm>
+          <a:prstGeom prst="rect">
+            <a:avLst/>
+          </a:prstGeom>
+          <a:noFill/>
+          <a:ln/>
+        </p:spPr>
+        <p:txBody>
+          <a:bodyPr wrap="square" lIns="0" tIns="0" rIns="0" bIns="0" rtlCol="0" anchor="ctr"/>
+          <a:lstStyle/>
+          <a:p>
+            <a:pPr indent="0" marL="0">
+              <a:buNone/>
+            </a:pPr>
+            <a:r>
+              <a:rPr lang="en-US" sz="1600" dirty="0">
+                <a:solidFill>
+                  <a:srgbClr val="FFFFFF"/>
+                </a:solidFill>
+                <a:latin typeface="Calibri" pitchFamily="34" charset="0"/>
+                <a:ea typeface="Calibri" pitchFamily="34" charset="-122"/>
+                <a:cs typeface="Calibri" pitchFamily="34" charset="-120"/>
+              </a:rPr>
+              <a:t>Buffer stock tersedia, rak tidak pernah kosong</a:t>
+            </a:r>
+            <a:endParaRPr lang="en-US" sz="1600" dirty="0"/>
           </a:p>
         </p:txBody>
       </p:sp>
@@ -3557,7 +3687,7 @@
                 <a:ea typeface="Calibri" pitchFamily="34" charset="-122"/>
                 <a:cs typeface="Calibri" pitchFamily="34" charset="-120"/>
               </a:rPr>
-              <a:t>Susunan rak, warna dan layout mengikuti mock display terlampir.</a:t>
+              <a:t>Susunan rak mengikuti mock terlampir. Header dikirim tim VM dari Jakarta.</a:t>
             </a:r>
             <a:endParaRPr lang="en-US" sz="1600" dirty="0"/>
           </a:p>
@@ -3856,7 +3986,7 @@
                 <a:ea typeface="Calibri" pitchFamily="34" charset="-122"/>
                 <a:cs typeface="Calibri" pitchFamily="34" charset="-120"/>
               </a:rPr>
-              <a:t>Cetak POP A4</a:t>
+              <a:t>POP sementara</a:t>
             </a:r>
             <a:endParaRPr lang="en-US" sz="2000" dirty="0"/>
           </a:p>
@@ -3895,7 +4025,7 @@
                 <a:ea typeface="Calibri" pitchFamily="34" charset="-122"/>
                 <a:cs typeface="Calibri" pitchFamily="34" charset="-120"/>
               </a:rPr>
-              <a:t>Selama menunggu Media Produk Info dari VM, store wajib cetak POP A4 terlampir.</a:t>
+              <a:t>Display datang lebih dulu dari materi komunikasi? Cetak POP A4 dari Head Office di percetakan.</a:t>
             </a:r>
             <a:endParaRPr lang="en-US" sz="1600" dirty="0"/>
           </a:p>
@@ -3988,8 +4118,8 @@
         </p:blipFill>
         <p:spPr>
           <a:xfrm>
-            <a:off x="548640" y="1097280"/>
-            <a:ext cx="5394960" cy="5724144"/>
+            <a:off x="731520" y="1097280"/>
+            <a:ext cx="4937760" cy="5556879"/>
           </a:xfrm>
           <a:prstGeom prst="rect">
             <a:avLst/>
@@ -4110,7 +4240,7 @@
                 <a:ea typeface="Calibri" pitchFamily="34" charset="-122"/>
                 <a:cs typeface="Calibri" pitchFamily="34" charset="-120"/>
               </a:rPr>
-              <a:t>“Pick Your Lucky Box” di bagian atas endcap.</a:t>
+              <a:t>“Pick Your Lucky Box”, dikirim tim VM dari Jakarta.</a:t>
             </a:r>
             <a:endParaRPr lang="en-US" sz="1800" dirty="0"/>
           </a:p>
@@ -20590,7 +20720,7 @@
                 <a:ea typeface="Cambria" pitchFamily="34" charset="-122"/>
                 <a:cs typeface="Cambria" pitchFamily="34" charset="-120"/>
               </a:rPr>
-              <a:t>Buka 6 warna dan cetak POP A4</a:t>
+              <a:t>Buka 6 warna, header, dan POP</a:t>
             </a:r>
             <a:endParaRPr lang="en-US" sz="3600" dirty="0"/>
           </a:p>
@@ -21130,7 +21260,7 @@
                 <a:ea typeface="Calibri" pitchFamily="34" charset="-122"/>
                 <a:cs typeface="Calibri" pitchFamily="34" charset="-120"/>
               </a:rPr>
-              <a:t>POP A4 wajib dicetak</a:t>
+              <a:t>Header dan POP sementara</a:t>
             </a:r>
             <a:endParaRPr lang="en-US" sz="2000" dirty="0"/>
           </a:p>
@@ -21145,11 +21275,11 @@
         <p:spPr>
           <a:xfrm>
             <a:off x="6583680" y="1920240"/>
-            <a:ext cx="2194560" cy="3017520"/>
+            <a:ext cx="1737360" cy="3017520"/>
           </a:xfrm>
           <a:prstGeom prst="roundRect">
             <a:avLst>
-              <a:gd name="adj" fmla="val 4167"/>
+              <a:gd name="adj" fmla="val 5263"/>
             </a:avLst>
           </a:prstGeom>
           <a:solidFill>
@@ -21172,7 +21302,7 @@
         <p:spPr>
           <a:xfrm>
             <a:off x="6583680" y="1920240"/>
-            <a:ext cx="2194560" cy="3017520"/>
+            <a:ext cx="1737360" cy="3017520"/>
           </a:xfrm>
           <a:prstGeom prst="rect">
             <a:avLst/>
@@ -21210,8 +21340,8 @@
         </p:nvSpPr>
         <p:spPr>
           <a:xfrm>
-            <a:off x="9052560" y="1920240"/>
-            <a:ext cx="2560320" cy="3017520"/>
+            <a:off x="8503920" y="1920240"/>
+            <a:ext cx="3108960" cy="3840480"/>
           </a:xfrm>
           <a:prstGeom prst="rect">
             <a:avLst/>
@@ -21231,7 +21361,7 @@
               <a:buChar char="•"/>
             </a:pPr>
             <a:r>
-              <a:rPr lang="en-US" sz="1500" dirty="0">
+              <a:rPr lang="en-US" sz="1400" dirty="0">
                 <a:solidFill>
                   <a:srgbClr val="3B2A5C"/>
                 </a:solidFill>
@@ -21239,9 +21369,9 @@
                 <a:ea typeface="Calibri" pitchFamily="34" charset="-122"/>
                 <a:cs typeface="Calibri" pitchFamily="34" charset="-120"/>
               </a:rPr>
-              <a:t>Cetak ukuran A4</a:t>
+              <a:t>Header dikirim tim VM dari Jakarta, pasang saat tiba</a:t>
             </a:r>
-            <a:endParaRPr lang="en-US" sz="1500" dirty="0"/>
+            <a:endParaRPr lang="en-US" sz="1400" dirty="0"/>
           </a:p>
           <a:p>
             <a:pPr marL="342900" indent="-342900">
@@ -21252,7 +21382,7 @@
               <a:buChar char="•"/>
             </a:pPr>
             <a:r>
-              <a:rPr lang="en-US" sz="1500" dirty="0">
+              <a:rPr lang="en-US" sz="1400" dirty="0">
                 <a:solidFill>
                   <a:srgbClr val="3B2A5C"/>
                 </a:solidFill>
@@ -21260,9 +21390,9 @@
                 <a:ea typeface="Calibri" pitchFamily="34" charset="-122"/>
                 <a:cs typeface="Calibri" pitchFamily="34" charset="-120"/>
               </a:rPr>
-              <a:t>Pasang di endcap Thermal</a:t>
+              <a:t>Display tiba lebih dulu dari materi komunikasi: cetak POP A4 sementara dari Head Office</a:t>
             </a:r>
-            <a:endParaRPr lang="en-US" sz="1500" dirty="0"/>
+            <a:endParaRPr lang="en-US" sz="1400" dirty="0"/>
           </a:p>
           <a:p>
             <a:pPr marL="342900" indent="-342900">
@@ -21273,7 +21403,7 @@
               <a:buChar char="•"/>
             </a:pPr>
             <a:r>
-              <a:rPr lang="en-US" sz="1500" dirty="0">
+              <a:rPr lang="en-US" sz="1400" dirty="0">
                 <a:solidFill>
                   <a:srgbClr val="3B2A5C"/>
                 </a:solidFill>
@@ -21281,9 +21411,30 @@
                 <a:ea typeface="Calibri" pitchFamily="34" charset="-122"/>
                 <a:cs typeface="Calibri" pitchFamily="34" charset="-120"/>
               </a:rPr>
-              <a:t>Berlaku sampai Media Produk Info dari VM terpasang</a:t>
+              <a:t>Cetak wajib di percetakan</a:t>
             </a:r>
-            <a:endParaRPr lang="en-US" sz="1500" dirty="0"/>
+            <a:endParaRPr lang="en-US" sz="1400" dirty="0"/>
+          </a:p>
+          <a:p>
+            <a:pPr marL="342900" indent="-342900">
+              <a:spcAft>
+                <a:spcPts val="800"/>
+              </a:spcAft>
+              <a:buSzPct val="100000"/>
+              <a:buChar char="•"/>
+            </a:pPr>
+            <a:r>
+              <a:rPr lang="en-US" sz="1400" dirty="0">
+                <a:solidFill>
+                  <a:srgbClr val="3B2A5C"/>
+                </a:solidFill>
+                <a:latin typeface="Calibri" pitchFamily="34" charset="0"/>
+                <a:ea typeface="Calibri" pitchFamily="34" charset="-122"/>
+                <a:cs typeface="Calibri" pitchFamily="34" charset="-120"/>
+              </a:rPr>
+              <a:t>Dipakai sampai Media Produk Info dari VM terpasang</a:t>
+            </a:r>
+            <a:endParaRPr lang="en-US" sz="1400" dirty="0"/>
           </a:p>
         </p:txBody>
       </p:sp>
@@ -21513,13 +21664,13 @@
           <a:p>
             <a:pPr marL="342900" indent="-342900">
               <a:spcAft>
-                <a:spcPts val="1200"/>
+                <a:spcPts val="800"/>
               </a:spcAft>
               <a:buSzPct val="100000"/>
               <a:buChar char="•"/>
             </a:pPr>
             <a:r>
-              <a:rPr lang="en-US" sz="1800" dirty="0">
+              <a:rPr lang="en-US" sz="1500" dirty="0">
                 <a:solidFill>
                   <a:srgbClr val="3B2A5C"/>
                 </a:solidFill>
@@ -21529,18 +21680,18 @@
               </a:rPr>
               <a:t>Pasang di Endcap Area Thermal, full terisi sesuai planogram dan mock</a:t>
             </a:r>
-            <a:endParaRPr lang="en-US" sz="1800" dirty="0"/>
+            <a:endParaRPr lang="en-US" sz="1500" dirty="0"/>
           </a:p>
           <a:p>
             <a:pPr marL="342900" indent="-342900">
               <a:spcAft>
-                <a:spcPts val="1200"/>
+                <a:spcPts val="800"/>
               </a:spcAft>
               <a:buSzPct val="100000"/>
               <a:buChar char="•"/>
             </a:pPr>
             <a:r>
-              <a:rPr lang="en-US" sz="1800" dirty="0">
+              <a:rPr lang="en-US" sz="1500" dirty="0">
                 <a:solidFill>
                   <a:srgbClr val="3B2A5C"/>
                 </a:solidFill>
@@ -21550,18 +21701,18 @@
               </a:rPr>
               <a:t>Buka hanya 6 warna sebagai sampel, sisanya tetap tersegel</a:t>
             </a:r>
-            <a:endParaRPr lang="en-US" sz="1800" dirty="0"/>
+            <a:endParaRPr lang="en-US" sz="1500" dirty="0"/>
           </a:p>
           <a:p>
             <a:pPr marL="342900" indent="-342900">
               <a:spcAft>
-                <a:spcPts val="1200"/>
+                <a:spcPts val="800"/>
               </a:spcAft>
               <a:buSzPct val="100000"/>
               <a:buChar char="•"/>
             </a:pPr>
             <a:r>
-              <a:rPr lang="en-US" sz="1800" dirty="0">
+              <a:rPr lang="en-US" sz="1500" dirty="0">
                 <a:solidFill>
                   <a:srgbClr val="3B2A5C"/>
                 </a:solidFill>
@@ -21571,18 +21722,18 @@
               </a:rPr>
               <a:t>Jaga box Secret tetap tersegel</a:t>
             </a:r>
-            <a:endParaRPr lang="en-US" sz="1800" dirty="0"/>
+            <a:endParaRPr lang="en-US" sz="1500" dirty="0"/>
           </a:p>
           <a:p>
             <a:pPr marL="342900" indent="-342900">
               <a:spcAft>
-                <a:spcPts val="1200"/>
+                <a:spcPts val="800"/>
               </a:spcAft>
               <a:buSzPct val="100000"/>
               <a:buChar char="•"/>
             </a:pPr>
             <a:r>
-              <a:rPr lang="en-US" sz="1800" dirty="0">
+              <a:rPr lang="en-US" sz="1500" dirty="0">
                 <a:solidFill>
                   <a:srgbClr val="3B2A5C"/>
                 </a:solidFill>
@@ -21592,18 +21743,18 @@
               </a:rPr>
               <a:t>Rapikan box, logo informa menghadap depan</a:t>
             </a:r>
-            <a:endParaRPr lang="en-US" sz="1800" dirty="0"/>
+            <a:endParaRPr lang="en-US" sz="1500" dirty="0"/>
           </a:p>
           <a:p>
             <a:pPr marL="342900" indent="-342900">
               <a:spcAft>
-                <a:spcPts val="1200"/>
+                <a:spcPts val="800"/>
               </a:spcAft>
               <a:buSzPct val="100000"/>
               <a:buChar char="•"/>
             </a:pPr>
             <a:r>
-              <a:rPr lang="en-US" sz="1800" dirty="0">
+              <a:rPr lang="en-US" sz="1500" dirty="0">
                 <a:solidFill>
                   <a:srgbClr val="3B2A5C"/>
                 </a:solidFill>
@@ -21613,18 +21764,18 @@
               </a:rPr>
               <a:t>Isi ulang rak dari buffer stock sebelum kosong</a:t>
             </a:r>
-            <a:endParaRPr lang="en-US" sz="1800" dirty="0"/>
+            <a:endParaRPr lang="en-US" sz="1500" dirty="0"/>
           </a:p>
           <a:p>
             <a:pPr marL="342900" indent="-342900">
               <a:spcAft>
-                <a:spcPts val="1200"/>
+                <a:spcPts val="800"/>
               </a:spcAft>
               <a:buSzPct val="100000"/>
               <a:buChar char="•"/>
             </a:pPr>
             <a:r>
-              <a:rPr lang="en-US" sz="1800" dirty="0">
+              <a:rPr lang="en-US" sz="1500" dirty="0">
                 <a:solidFill>
                   <a:srgbClr val="3B2A5C"/>
                 </a:solidFill>
@@ -21634,7 +21785,28 @@
               </a:rPr>
               <a:t>Jelaskan ke pelanggan: pilih warna favorit, Secret adalah kejutan</a:t>
             </a:r>
-            <a:endParaRPr lang="en-US" sz="1800" dirty="0"/>
+            <a:endParaRPr lang="en-US" sz="1500" dirty="0"/>
+          </a:p>
+          <a:p>
+            <a:pPr marL="342900" indent="-342900">
+              <a:spcAft>
+                <a:spcPts val="800"/>
+              </a:spcAft>
+              <a:buSzPct val="100000"/>
+              <a:buChar char="•"/>
+            </a:pPr>
+            <a:r>
+              <a:rPr lang="en-US" sz="1500" dirty="0">
+                <a:solidFill>
+                  <a:srgbClr val="3B2A5C"/>
+                </a:solidFill>
+                <a:latin typeface="Calibri" pitchFamily="34" charset="0"/>
+                <a:ea typeface="Calibri" pitchFamily="34" charset="-122"/>
+                <a:cs typeface="Calibri" pitchFamily="34" charset="-120"/>
+              </a:rPr>
+              <a:t>Cetak POP A4 sementara dari Head Office bila materi komunikasi belum tiba</a:t>
+            </a:r>
+            <a:endParaRPr lang="en-US" sz="1500" dirty="0"/>
           </a:p>
         </p:txBody>
       </p:sp>
@@ -21754,13 +21926,13 @@
           <a:p>
             <a:pPr marL="342900" indent="-342900">
               <a:spcAft>
-                <a:spcPts val="1200"/>
+                <a:spcPts val="800"/>
               </a:spcAft>
               <a:buSzPct val="100000"/>
               <a:buChar char="•"/>
             </a:pPr>
             <a:r>
-              <a:rPr lang="en-US" sz="1800" dirty="0">
+              <a:rPr lang="en-US" sz="1500" dirty="0">
                 <a:solidFill>
                   <a:srgbClr val="3B2A5C"/>
                 </a:solidFill>
@@ -21770,18 +21942,18 @@
               </a:rPr>
               <a:t>Jangan taruh di luar endcap Thermal atau campur dengan produk lain</a:t>
             </a:r>
-            <a:endParaRPr lang="en-US" sz="1800" dirty="0"/>
+            <a:endParaRPr lang="en-US" sz="1500" dirty="0"/>
           </a:p>
           <a:p>
             <a:pPr marL="342900" indent="-342900">
               <a:spcAft>
-                <a:spcPts val="1200"/>
+                <a:spcPts val="800"/>
               </a:spcAft>
               <a:buSzPct val="100000"/>
               <a:buChar char="•"/>
             </a:pPr>
             <a:r>
-              <a:rPr lang="en-US" sz="1800" dirty="0">
+              <a:rPr lang="en-US" sz="1500" dirty="0">
                 <a:solidFill>
                   <a:srgbClr val="3B2A5C"/>
                 </a:solidFill>
@@ -21791,18 +21963,18 @@
               </a:rPr>
               <a:t>Jangan biarkan rak kosong atau terisi sebagian</a:t>
             </a:r>
-            <a:endParaRPr lang="en-US" sz="1800" dirty="0"/>
+            <a:endParaRPr lang="en-US" sz="1500" dirty="0"/>
           </a:p>
           <a:p>
             <a:pPr marL="342900" indent="-342900">
               <a:spcAft>
-                <a:spcPts val="1200"/>
+                <a:spcPts val="800"/>
               </a:spcAft>
               <a:buSzPct val="100000"/>
               <a:buChar char="•"/>
             </a:pPr>
             <a:r>
-              <a:rPr lang="en-US" sz="1800" dirty="0">
+              <a:rPr lang="en-US" sz="1500" dirty="0">
                 <a:solidFill>
                   <a:srgbClr val="3B2A5C"/>
                 </a:solidFill>
@@ -21812,18 +21984,18 @@
               </a:rPr>
               <a:t>Jangan buka atau sobek box selain sampel 6 warna</a:t>
             </a:r>
-            <a:endParaRPr lang="en-US" sz="1800" dirty="0"/>
+            <a:endParaRPr lang="en-US" sz="1500" dirty="0"/>
           </a:p>
           <a:p>
             <a:pPr marL="342900" indent="-342900">
               <a:spcAft>
-                <a:spcPts val="1200"/>
+                <a:spcPts val="800"/>
               </a:spcAft>
               <a:buSzPct val="100000"/>
               <a:buChar char="•"/>
             </a:pPr>
             <a:r>
-              <a:rPr lang="en-US" sz="1800" dirty="0">
+              <a:rPr lang="en-US" sz="1500" dirty="0">
                 <a:solidFill>
                   <a:srgbClr val="3B2A5C"/>
                 </a:solidFill>
@@ -21833,18 +22005,18 @@
               </a:rPr>
               <a:t>Jangan bocorkan isi box tersegel (ditimbang, diguncang, atau diberi petunjuk)</a:t>
             </a:r>
-            <a:endParaRPr lang="en-US" sz="1800" dirty="0"/>
+            <a:endParaRPr lang="en-US" sz="1500" dirty="0"/>
           </a:p>
           <a:p>
             <a:pPr marL="342900" indent="-342900">
               <a:spcAft>
-                <a:spcPts val="1200"/>
+                <a:spcPts val="800"/>
               </a:spcAft>
               <a:buSzPct val="100000"/>
               <a:buChar char="•"/>
             </a:pPr>
             <a:r>
-              <a:rPr lang="en-US" sz="1800" dirty="0">
+              <a:rPr lang="en-US" sz="1500" dirty="0">
                 <a:solidFill>
                   <a:srgbClr val="3B2A5C"/>
                 </a:solidFill>
@@ -21854,18 +22026,18 @@
               </a:rPr>
               <a:t>Jangan ubah susunan, qty, atau tinggi rak</a:t>
             </a:r>
-            <a:endParaRPr lang="en-US" sz="1800" dirty="0"/>
+            <a:endParaRPr lang="en-US" sz="1500" dirty="0"/>
           </a:p>
           <a:p>
             <a:pPr marL="342900" indent="-342900">
               <a:spcAft>
-                <a:spcPts val="1200"/>
+                <a:spcPts val="800"/>
               </a:spcAft>
               <a:buSzPct val="100000"/>
               <a:buChar char="•"/>
             </a:pPr>
             <a:r>
-              <a:rPr lang="en-US" sz="1800" dirty="0">
+              <a:rPr lang="en-US" sz="1500" dirty="0">
                 <a:solidFill>
                   <a:srgbClr val="3B2A5C"/>
                 </a:solidFill>
@@ -21875,7 +22047,28 @@
               </a:rPr>
               <a:t>Jangan jual unit sampel yang sudah dibuka sebagai produk baru</a:t>
             </a:r>
-            <a:endParaRPr lang="en-US" sz="1800" dirty="0"/>
+            <a:endParaRPr lang="en-US" sz="1500" dirty="0"/>
+          </a:p>
+          <a:p>
+            <a:pPr marL="342900" indent="-342900">
+              <a:spcAft>
+                <a:spcPts val="800"/>
+              </a:spcAft>
+              <a:buSzPct val="100000"/>
+              <a:buChar char="•"/>
+            </a:pPr>
+            <a:r>
+              <a:rPr lang="en-US" sz="1500" dirty="0">
+                <a:solidFill>
+                  <a:srgbClr val="3B2A5C"/>
+                </a:solidFill>
+                <a:latin typeface="Calibri" pitchFamily="34" charset="0"/>
+                <a:ea typeface="Calibri" pitchFamily="34" charset="-122"/>
+                <a:cs typeface="Calibri" pitchFamily="34" charset="-120"/>
+              </a:rPr>
+              <a:t>Jangan cetak POP sementara selain di percetakan</a:t>
+            </a:r>
+            <a:endParaRPr lang="en-US" sz="1500" dirty="0"/>
           </a:p>
         </p:txBody>
       </p:sp>

</xml_diff>

<commit_message>
Add 3D planogram rack, PDQ opening steps, Secret handling
Co-Authored-By: Claude Sonnet 5.5 <noreply@anthropic.com>
Claude-Session: https://claude.ai/code/session_01WvUriRkWqtmHorCL8uL8C7
</commit_message>
<xml_diff>
--- a/Instruksi_Display_Blind_Box_Thermal.pptx
+++ b/Instruksi_Display_Blind_Box_Thermal.pptx
@@ -15,9 +15,10 @@
     <p:sldId id="263" r:id="rId9"/>
     <p:sldId id="264" r:id="rId10"/>
     <p:sldId id="265" r:id="rId11"/>
+    <p:sldId id="266" r:id="rId12"/>
   </p:sldIdLst>
   <p:notesMasterIdLst>
-    <p:notesMasterId r:id="rId12"/>
+    <p:notesMasterId r:id="rId13"/>
   </p:notesMasterIdLst>
   <p:sldSz cx="12192000" cy="6858000"/>
   <p:notesSz cx="6858000" cy="12192000"/>
@@ -623,6 +624,94 @@
             <a:fld id="{F7021451-1387-4CA6-816F-3879F97B5CBC}" type="slidenum">
               <a:rPr lang="en-US"/>
               <a:t>10</a:t>
+            </a:fld>
+            <a:endParaRPr lang="en-US"/>
+          </a:p>
+        </p:txBody>
+      </p:sp>
+    </p:spTree>
+    <p:extLst>
+      <p:ext uri="{BB962C8B-B14F-4D97-AF65-F5344CB8AC3E}">
+        <p14:creationId xmlns:p14="http://schemas.microsoft.com/office/powerpoint/2010/main" val="1024086991"/>
+      </p:ext>
+    </p:extLst>
+  </p:cSld>
+  <p:clrMapOvr>
+    <a:masterClrMapping/>
+  </p:clrMapOvr>
+</p:notes>
+</file>
+
+<file path=ppt/notesSlides/notesSlide11.xml><?xml version="1.0" encoding="utf-8"?>
+<p:notes xmlns:a="http://schemas.openxmlformats.org/drawingml/2006/main" xmlns:r="http://schemas.openxmlformats.org/officeDocument/2006/relationships" xmlns:p="http://schemas.openxmlformats.org/presentationml/2006/main">
+  <p:cSld>
+    <p:spTree>
+      <p:nvGrpSpPr>
+        <p:cNvPr id="1" name=""/>
+        <p:cNvGrpSpPr/>
+        <p:nvPr/>
+      </p:nvGrpSpPr>
+      <p:grpSpPr>
+        <a:xfrm>
+          <a:off x="0" y="0"/>
+          <a:ext cx="0" cy="0"/>
+          <a:chOff x="0" y="0"/>
+          <a:chExt cx="0" cy="0"/>
+        </a:xfrm>
+      </p:grpSpPr>
+      <p:sp>
+        <p:nvSpPr>
+          <p:cNvPr id="2" name="Slide Image Placeholder 1"/>
+          <p:cNvSpPr>
+            <a:spLocks noGrp="1" noRot="1" noChangeAspect="1"/>
+          </p:cNvSpPr>
+          <p:nvPr>
+            <p:ph type="sldImg"/>
+          </p:nvPr>
+        </p:nvSpPr>
+        <p:spPr/>
+      </p:sp>
+      <p:sp>
+        <p:nvSpPr>
+          <p:cNvPr id="3" name="Notes Placeholder 2"/>
+          <p:cNvSpPr>
+            <a:spLocks noGrp="1"/>
+          </p:cNvSpPr>
+          <p:nvPr>
+            <p:ph type="body" idx="1"/>
+          </p:nvPr>
+        </p:nvSpPr>
+        <p:spPr/>
+        <p:txBody>
+          <a:bodyPr/>
+          <a:lstStyle/>
+          <a:p>
+            <a:r>
+              <a:rPr lang="en-US" dirty="0"/>
+              <a:t/>
+            </a:r>
+            <a:endParaRPr lang="en-US" dirty="0"/>
+          </a:p>
+        </p:txBody>
+      </p:sp>
+      <p:sp>
+        <p:nvSpPr>
+          <p:cNvPr id="4" name="Slide Number Placeholder 3"/>
+          <p:cNvSpPr>
+            <a:spLocks noGrp="1"/>
+          </p:cNvSpPr>
+          <p:nvPr>
+            <p:ph type="sldNum" sz="quarter" idx="10"/>
+          </p:nvPr>
+        </p:nvSpPr>
+        <p:spPr/>
+        <p:txBody>
+          <a:bodyPr/>
+          <a:lstStyle/>
+          <a:p>
+            <a:fld id="{F7021451-1387-4CA6-816F-3879F97B5CBC}" type="slidenum">
+              <a:rPr lang="en-US"/>
+              <a:t>11</a:t>
             </a:fld>
             <a:endParaRPr lang="en-US"/>
           </a:p>
@@ -1940,6 +2029,640 @@
     <p:bg>
       <p:bgPr>
         <a:solidFill>
+          <a:srgbClr val="FFFFFF"/>
+        </a:solidFill>
+      </p:bgPr>
+    </p:bg>
+    <p:spTree>
+      <p:nvGrpSpPr>
+        <p:cNvPr id="1" name=""/>
+        <p:cNvGrpSpPr/>
+        <p:nvPr/>
+      </p:nvGrpSpPr>
+      <p:grpSpPr>
+        <a:xfrm>
+          <a:off x="0" y="0"/>
+          <a:ext cx="0" cy="0"/>
+          <a:chOff x="0" y="0"/>
+          <a:chExt cx="0" cy="0"/>
+        </a:xfrm>
+      </p:grpSpPr>
+      <p:sp>
+        <p:nvSpPr>
+          <p:cNvPr id="2" name="Text 0"/>
+          <p:cNvSpPr txBox="1"/>
+          <p:nvPr/>
+        </p:nvSpPr>
+        <p:spPr>
+          <a:xfrm>
+            <a:off x="548640" y="365760"/>
+            <a:ext cx="11064240" cy="731520"/>
+          </a:xfrm>
+          <a:prstGeom prst="rect">
+            <a:avLst/>
+          </a:prstGeom>
+          <a:noFill/>
+          <a:ln/>
+        </p:spPr>
+        <p:txBody>
+          <a:bodyPr wrap="square" lIns="0" tIns="0" rIns="0" bIns="0" rtlCol="0" anchor="ctr"/>
+          <a:lstStyle/>
+          <a:p>
+            <a:pPr indent="0" marL="0">
+              <a:buNone/>
+            </a:pPr>
+            <a:r>
+              <a:rPr lang="en-US" sz="3600" b="1" dirty="0">
+                <a:solidFill>
+                  <a:srgbClr val="3B2A5C"/>
+                </a:solidFill>
+                <a:latin typeface="Cambria" pitchFamily="34" charset="0"/>
+                <a:ea typeface="Cambria" pitchFamily="34" charset="-122"/>
+                <a:cs typeface="Cambria" pitchFamily="34" charset="-120"/>
+              </a:rPr>
+              <a:t>Do dan Don'ts display dan penjualan</a:t>
+            </a:r>
+            <a:endParaRPr lang="en-US" sz="3600" dirty="0"/>
+          </a:p>
+        </p:txBody>
+      </p:sp>
+      <p:sp>
+        <p:nvSpPr>
+          <p:cNvPr id="3" name="Text 1"/>
+          <p:cNvSpPr txBox="1"/>
+          <p:nvPr/>
+        </p:nvSpPr>
+        <p:spPr>
+          <a:xfrm>
+            <a:off x="548640" y="1051560"/>
+            <a:ext cx="11064240" cy="365760"/>
+          </a:xfrm>
+          <a:prstGeom prst="rect">
+            <a:avLst/>
+          </a:prstGeom>
+          <a:noFill/>
+          <a:ln/>
+        </p:spPr>
+        <p:txBody>
+          <a:bodyPr wrap="square" lIns="0" tIns="0" rIns="0" bIns="0" rtlCol="0" anchor="ctr"/>
+          <a:lstStyle/>
+          <a:p>
+            <a:pPr indent="0" marL="0">
+              <a:buNone/>
+            </a:pPr>
+            <a:r>
+              <a:rPr lang="en-US" sz="1600" dirty="0">
+                <a:solidFill>
+                  <a:srgbClr val="6B6580"/>
+                </a:solidFill>
+                <a:latin typeface="Calibri" pitchFamily="34" charset="0"/>
+                <a:ea typeface="Calibri" pitchFamily="34" charset="-122"/>
+                <a:cs typeface="Calibri" pitchFamily="34" charset="-120"/>
+              </a:rPr>
+              <a:t>Rekomendasi untuk tim store</a:t>
+            </a:r>
+            <a:endParaRPr lang="en-US" sz="1600" dirty="0"/>
+          </a:p>
+        </p:txBody>
+      </p:sp>
+      <p:sp>
+        <p:nvSpPr>
+          <p:cNvPr id="4" name="Shape 2"/>
+          <p:cNvSpPr/>
+          <p:nvPr/>
+        </p:nvSpPr>
+        <p:spPr>
+          <a:xfrm>
+            <a:off x="548640" y="1645920"/>
+            <a:ext cx="5349240" cy="4754880"/>
+          </a:xfrm>
+          <a:prstGeom prst="roundRect">
+            <a:avLst>
+              <a:gd name="adj" fmla="val 2885"/>
+            </a:avLst>
+          </a:prstGeom>
+          <a:solidFill>
+            <a:srgbClr val="E3F6FB"/>
+          </a:solidFill>
+          <a:ln w="12700">
+            <a:solidFill>
+              <a:srgbClr val="E3F6FB"/>
+            </a:solidFill>
+            <a:prstDash val="solid"/>
+          </a:ln>
+        </p:spPr>
+      </p:sp>
+      <p:sp>
+        <p:nvSpPr>
+          <p:cNvPr id="5" name="Shape 3"/>
+          <p:cNvSpPr/>
+          <p:nvPr/>
+        </p:nvSpPr>
+        <p:spPr>
+          <a:xfrm>
+            <a:off x="822960" y="1828800"/>
+            <a:ext cx="1371600" cy="457200"/>
+          </a:xfrm>
+          <a:prstGeom prst="roundRect">
+            <a:avLst>
+              <a:gd name="adj" fmla="val 50000"/>
+            </a:avLst>
+          </a:prstGeom>
+          <a:solidFill>
+            <a:srgbClr val="4DC3E0"/>
+          </a:solidFill>
+          <a:ln w="12700">
+            <a:solidFill>
+              <a:srgbClr val="4DC3E0"/>
+            </a:solidFill>
+            <a:prstDash val="solid"/>
+          </a:ln>
+        </p:spPr>
+      </p:sp>
+      <p:sp>
+        <p:nvSpPr>
+          <p:cNvPr id="6" name="Text 4"/>
+          <p:cNvSpPr txBox="1"/>
+          <p:nvPr/>
+        </p:nvSpPr>
+        <p:spPr>
+          <a:xfrm>
+            <a:off x="822960" y="1828800"/>
+            <a:ext cx="1371600" cy="457200"/>
+          </a:xfrm>
+          <a:prstGeom prst="rect">
+            <a:avLst/>
+          </a:prstGeom>
+          <a:noFill/>
+          <a:ln/>
+        </p:spPr>
+        <p:txBody>
+          <a:bodyPr wrap="square" lIns="0" tIns="0" rIns="0" bIns="0" rtlCol="0" anchor="ctr"/>
+          <a:lstStyle/>
+          <a:p>
+            <a:pPr algn="ctr" indent="0" marL="0">
+              <a:buNone/>
+            </a:pPr>
+            <a:r>
+              <a:rPr lang="en-US" sz="1800" b="1" dirty="0">
+                <a:solidFill>
+                  <a:srgbClr val="FFFFFF"/>
+                </a:solidFill>
+                <a:latin typeface="Calibri" pitchFamily="34" charset="0"/>
+                <a:ea typeface="Calibri" pitchFamily="34" charset="-122"/>
+                <a:cs typeface="Calibri" pitchFamily="34" charset="-120"/>
+              </a:rPr>
+              <a:t>DO</a:t>
+            </a:r>
+            <a:endParaRPr lang="en-US" sz="1800" dirty="0"/>
+          </a:p>
+        </p:txBody>
+      </p:sp>
+      <p:sp>
+        <p:nvSpPr>
+          <p:cNvPr id="7" name="Text 5"/>
+          <p:cNvSpPr txBox="1"/>
+          <p:nvPr/>
+        </p:nvSpPr>
+        <p:spPr>
+          <a:xfrm>
+            <a:off x="822960" y="2514600"/>
+            <a:ext cx="4800600" cy="3749040"/>
+          </a:xfrm>
+          <a:prstGeom prst="rect">
+            <a:avLst/>
+          </a:prstGeom>
+          <a:noFill/>
+          <a:ln/>
+        </p:spPr>
+        <p:txBody>
+          <a:bodyPr wrap="square" lIns="0" tIns="0" rIns="0" bIns="0" rtlCol="0" anchor="t"/>
+          <a:lstStyle/>
+          <a:p>
+            <a:pPr marL="342900" indent="-342900">
+              <a:spcAft>
+                <a:spcPts val="800"/>
+              </a:spcAft>
+              <a:buSzPct val="100000"/>
+              <a:buChar char="•"/>
+            </a:pPr>
+            <a:r>
+              <a:rPr lang="en-US" sz="1500" dirty="0">
+                <a:solidFill>
+                  <a:srgbClr val="3B2A5C"/>
+                </a:solidFill>
+                <a:latin typeface="Calibri" pitchFamily="34" charset="0"/>
+                <a:ea typeface="Calibri" pitchFamily="34" charset="-122"/>
+                <a:cs typeface="Calibri" pitchFamily="34" charset="-120"/>
+              </a:rPr>
+              <a:t>Pasang di Endcap Area Thermal, full terisi sesuai planogram dan mock</a:t>
+            </a:r>
+            <a:endParaRPr lang="en-US" sz="1500" dirty="0"/>
+          </a:p>
+          <a:p>
+            <a:pPr marL="342900" indent="-342900">
+              <a:spcAft>
+                <a:spcPts val="800"/>
+              </a:spcAft>
+              <a:buSzPct val="100000"/>
+              <a:buChar char="•"/>
+            </a:pPr>
+            <a:r>
+              <a:rPr lang="en-US" sz="1500" dirty="0">
+                <a:solidFill>
+                  <a:srgbClr val="3B2A5C"/>
+                </a:solidFill>
+                <a:latin typeface="Calibri" pitchFamily="34" charset="0"/>
+                <a:ea typeface="Calibri" pitchFamily="34" charset="-122"/>
+                <a:cs typeface="Calibri" pitchFamily="34" charset="-120"/>
+              </a:rPr>
+              <a:t>Buka 1 PDQ SMALL dan 1 PDQ LARGE sebagai sampel, sisanya tetap tersegel</a:t>
+            </a:r>
+            <a:endParaRPr lang="en-US" sz="1500" dirty="0"/>
+          </a:p>
+          <a:p>
+            <a:pPr marL="342900" indent="-342900">
+              <a:spcAft>
+                <a:spcPts val="800"/>
+              </a:spcAft>
+              <a:buSzPct val="100000"/>
+              <a:buChar char="•"/>
+            </a:pPr>
+            <a:r>
+              <a:rPr lang="en-US" sz="1500" dirty="0">
+                <a:solidFill>
+                  <a:srgbClr val="3B2A5C"/>
+                </a:solidFill>
+                <a:latin typeface="Calibri" pitchFamily="34" charset="0"/>
+                <a:ea typeface="Calibri" pitchFamily="34" charset="-122"/>
+                <a:cs typeface="Calibri" pitchFamily="34" charset="-120"/>
+              </a:rPr>
+              <a:t>Amankan Secret bila didapat, lalu display 5 warna</a:t>
+            </a:r>
+            <a:endParaRPr lang="en-US" sz="1500" dirty="0"/>
+          </a:p>
+          <a:p>
+            <a:pPr marL="342900" indent="-342900">
+              <a:spcAft>
+                <a:spcPts val="800"/>
+              </a:spcAft>
+              <a:buSzPct val="100000"/>
+              <a:buChar char="•"/>
+            </a:pPr>
+            <a:r>
+              <a:rPr lang="en-US" sz="1500" dirty="0">
+                <a:solidFill>
+                  <a:srgbClr val="3B2A5C"/>
+                </a:solidFill>
+                <a:latin typeface="Calibri" pitchFamily="34" charset="0"/>
+                <a:ea typeface="Calibri" pitchFamily="34" charset="-122"/>
+                <a:cs typeface="Calibri" pitchFamily="34" charset="-120"/>
+              </a:rPr>
+              <a:t>Buka kardus pelan-pelan dan ikuti video tutorial MD</a:t>
+            </a:r>
+            <a:endParaRPr lang="en-US" sz="1500" dirty="0"/>
+          </a:p>
+          <a:p>
+            <a:pPr marL="342900" indent="-342900">
+              <a:spcAft>
+                <a:spcPts val="800"/>
+              </a:spcAft>
+              <a:buSzPct val="100000"/>
+              <a:buChar char="•"/>
+            </a:pPr>
+            <a:r>
+              <a:rPr lang="en-US" sz="1500" dirty="0">
+                <a:solidFill>
+                  <a:srgbClr val="3B2A5C"/>
+                </a:solidFill>
+                <a:latin typeface="Calibri" pitchFamily="34" charset="0"/>
+                <a:ea typeface="Calibri" pitchFamily="34" charset="-122"/>
+                <a:cs typeface="Calibri" pitchFamily="34" charset="-120"/>
+              </a:rPr>
+              <a:t>Isi ulang rak dari buffer stock sebelum kosong</a:t>
+            </a:r>
+            <a:endParaRPr lang="en-US" sz="1500" dirty="0"/>
+          </a:p>
+          <a:p>
+            <a:pPr marL="342900" indent="-342900">
+              <a:spcAft>
+                <a:spcPts val="800"/>
+              </a:spcAft>
+              <a:buSzPct val="100000"/>
+              <a:buChar char="•"/>
+            </a:pPr>
+            <a:r>
+              <a:rPr lang="en-US" sz="1500" dirty="0">
+                <a:solidFill>
+                  <a:srgbClr val="3B2A5C"/>
+                </a:solidFill>
+                <a:latin typeface="Calibri" pitchFamily="34" charset="0"/>
+                <a:ea typeface="Calibri" pitchFamily="34" charset="-122"/>
+                <a:cs typeface="Calibri" pitchFamily="34" charset="-120"/>
+              </a:rPr>
+              <a:t>Jelaskan ke pelanggan: pilih warna favorit, Secret adalah kejutan</a:t>
+            </a:r>
+            <a:endParaRPr lang="en-US" sz="1500" dirty="0"/>
+          </a:p>
+          <a:p>
+            <a:pPr marL="342900" indent="-342900">
+              <a:spcAft>
+                <a:spcPts val="800"/>
+              </a:spcAft>
+              <a:buSzPct val="100000"/>
+              <a:buChar char="•"/>
+            </a:pPr>
+            <a:r>
+              <a:rPr lang="en-US" sz="1500" dirty="0">
+                <a:solidFill>
+                  <a:srgbClr val="3B2A5C"/>
+                </a:solidFill>
+                <a:latin typeface="Calibri" pitchFamily="34" charset="0"/>
+                <a:ea typeface="Calibri" pitchFamily="34" charset="-122"/>
+                <a:cs typeface="Calibri" pitchFamily="34" charset="-120"/>
+              </a:rPr>
+              <a:t>Cetak POP A4 sementara dari Head Office bila materi komunikasi belum tiba</a:t>
+            </a:r>
+            <a:endParaRPr lang="en-US" sz="1500" dirty="0"/>
+          </a:p>
+        </p:txBody>
+      </p:sp>
+      <p:sp>
+        <p:nvSpPr>
+          <p:cNvPr id="8" name="Shape 6"/>
+          <p:cNvSpPr/>
+          <p:nvPr/>
+        </p:nvSpPr>
+        <p:spPr>
+          <a:xfrm>
+            <a:off x="6263640" y="1645920"/>
+            <a:ext cx="5349240" cy="4754880"/>
+          </a:xfrm>
+          <a:prstGeom prst="roundRect">
+            <a:avLst>
+              <a:gd name="adj" fmla="val 2885"/>
+            </a:avLst>
+          </a:prstGeom>
+          <a:solidFill>
+            <a:srgbClr val="FDEAF3"/>
+          </a:solidFill>
+          <a:ln w="12700">
+            <a:solidFill>
+              <a:srgbClr val="FDEAF3"/>
+            </a:solidFill>
+            <a:prstDash val="solid"/>
+          </a:ln>
+        </p:spPr>
+      </p:sp>
+      <p:sp>
+        <p:nvSpPr>
+          <p:cNvPr id="9" name="Shape 7"/>
+          <p:cNvSpPr/>
+          <p:nvPr/>
+        </p:nvSpPr>
+        <p:spPr>
+          <a:xfrm>
+            <a:off x="6537960" y="1828800"/>
+            <a:ext cx="1371600" cy="457200"/>
+          </a:xfrm>
+          <a:prstGeom prst="roundRect">
+            <a:avLst>
+              <a:gd name="adj" fmla="val 50000"/>
+            </a:avLst>
+          </a:prstGeom>
+          <a:solidFill>
+            <a:srgbClr val="F27BB0"/>
+          </a:solidFill>
+          <a:ln w="12700">
+            <a:solidFill>
+              <a:srgbClr val="F27BB0"/>
+            </a:solidFill>
+            <a:prstDash val="solid"/>
+          </a:ln>
+        </p:spPr>
+      </p:sp>
+      <p:sp>
+        <p:nvSpPr>
+          <p:cNvPr id="10" name="Text 8"/>
+          <p:cNvSpPr txBox="1"/>
+          <p:nvPr/>
+        </p:nvSpPr>
+        <p:spPr>
+          <a:xfrm>
+            <a:off x="6537960" y="1828800"/>
+            <a:ext cx="1371600" cy="457200"/>
+          </a:xfrm>
+          <a:prstGeom prst="rect">
+            <a:avLst/>
+          </a:prstGeom>
+          <a:noFill/>
+          <a:ln/>
+        </p:spPr>
+        <p:txBody>
+          <a:bodyPr wrap="square" lIns="0" tIns="0" rIns="0" bIns="0" rtlCol="0" anchor="ctr"/>
+          <a:lstStyle/>
+          <a:p>
+            <a:pPr algn="ctr" indent="0" marL="0">
+              <a:buNone/>
+            </a:pPr>
+            <a:r>
+              <a:rPr lang="en-US" sz="1800" b="1" dirty="0">
+                <a:solidFill>
+                  <a:srgbClr val="FFFFFF"/>
+                </a:solidFill>
+                <a:latin typeface="Calibri" pitchFamily="34" charset="0"/>
+                <a:ea typeface="Calibri" pitchFamily="34" charset="-122"/>
+                <a:cs typeface="Calibri" pitchFamily="34" charset="-120"/>
+              </a:rPr>
+              <a:t>DON'T</a:t>
+            </a:r>
+            <a:endParaRPr lang="en-US" sz="1800" dirty="0"/>
+          </a:p>
+        </p:txBody>
+      </p:sp>
+      <p:sp>
+        <p:nvSpPr>
+          <p:cNvPr id="11" name="Text 9"/>
+          <p:cNvSpPr txBox="1"/>
+          <p:nvPr/>
+        </p:nvSpPr>
+        <p:spPr>
+          <a:xfrm>
+            <a:off x="6537960" y="2514600"/>
+            <a:ext cx="4800600" cy="3749040"/>
+          </a:xfrm>
+          <a:prstGeom prst="rect">
+            <a:avLst/>
+          </a:prstGeom>
+          <a:noFill/>
+          <a:ln/>
+        </p:spPr>
+        <p:txBody>
+          <a:bodyPr wrap="square" lIns="0" tIns="0" rIns="0" bIns="0" rtlCol="0" anchor="t"/>
+          <a:lstStyle/>
+          <a:p>
+            <a:pPr marL="342900" indent="-342900">
+              <a:spcAft>
+                <a:spcPts val="800"/>
+              </a:spcAft>
+              <a:buSzPct val="100000"/>
+              <a:buChar char="•"/>
+            </a:pPr>
+            <a:r>
+              <a:rPr lang="en-US" sz="1500" dirty="0">
+                <a:solidFill>
+                  <a:srgbClr val="3B2A5C"/>
+                </a:solidFill>
+                <a:latin typeface="Calibri" pitchFamily="34" charset="0"/>
+                <a:ea typeface="Calibri" pitchFamily="34" charset="-122"/>
+                <a:cs typeface="Calibri" pitchFamily="34" charset="-120"/>
+              </a:rPr>
+              <a:t>Jangan taruh di luar endcap Thermal atau campur dengan produk lain</a:t>
+            </a:r>
+            <a:endParaRPr lang="en-US" sz="1500" dirty="0"/>
+          </a:p>
+          <a:p>
+            <a:pPr marL="342900" indent="-342900">
+              <a:spcAft>
+                <a:spcPts val="800"/>
+              </a:spcAft>
+              <a:buSzPct val="100000"/>
+              <a:buChar char="•"/>
+            </a:pPr>
+            <a:r>
+              <a:rPr lang="en-US" sz="1500" dirty="0">
+                <a:solidFill>
+                  <a:srgbClr val="3B2A5C"/>
+                </a:solidFill>
+                <a:latin typeface="Calibri" pitchFamily="34" charset="0"/>
+                <a:ea typeface="Calibri" pitchFamily="34" charset="-122"/>
+                <a:cs typeface="Calibri" pitchFamily="34" charset="-120"/>
+              </a:rPr>
+              <a:t>Jangan biarkan rak kosong atau terisi sebagian</a:t>
+            </a:r>
+            <a:endParaRPr lang="en-US" sz="1500" dirty="0"/>
+          </a:p>
+          <a:p>
+            <a:pPr marL="342900" indent="-342900">
+              <a:spcAft>
+                <a:spcPts val="800"/>
+              </a:spcAft>
+              <a:buSzPct val="100000"/>
+              <a:buChar char="•"/>
+            </a:pPr>
+            <a:r>
+              <a:rPr lang="en-US" sz="1500" dirty="0">
+                <a:solidFill>
+                  <a:srgbClr val="3B2A5C"/>
+                </a:solidFill>
+                <a:latin typeface="Calibri" pitchFamily="34" charset="0"/>
+                <a:ea typeface="Calibri" pitchFamily="34" charset="-122"/>
+                <a:cs typeface="Calibri" pitchFamily="34" charset="-120"/>
+              </a:rPr>
+              <a:t>Jangan buka PDQ selain 1 SMALL dan 1 LARGE</a:t>
+            </a:r>
+            <a:endParaRPr lang="en-US" sz="1500" dirty="0"/>
+          </a:p>
+          <a:p>
+            <a:pPr marL="342900" indent="-342900">
+              <a:spcAft>
+                <a:spcPts val="800"/>
+              </a:spcAft>
+              <a:buSzPct val="100000"/>
+              <a:buChar char="•"/>
+            </a:pPr>
+            <a:r>
+              <a:rPr lang="en-US" sz="1500" dirty="0">
+                <a:solidFill>
+                  <a:srgbClr val="3B2A5C"/>
+                </a:solidFill>
+                <a:latin typeface="Calibri" pitchFamily="34" charset="0"/>
+                <a:ea typeface="Calibri" pitchFamily="34" charset="-122"/>
+                <a:cs typeface="Calibri" pitchFamily="34" charset="-120"/>
+              </a:rPr>
+              <a:t>Jangan bocorkan isi box tersegel (ditimbang, diguncang, atau diberi petunjuk)</a:t>
+            </a:r>
+            <a:endParaRPr lang="en-US" sz="1500" dirty="0"/>
+          </a:p>
+          <a:p>
+            <a:pPr marL="342900" indent="-342900">
+              <a:spcAft>
+                <a:spcPts val="800"/>
+              </a:spcAft>
+              <a:buSzPct val="100000"/>
+              <a:buChar char="•"/>
+            </a:pPr>
+            <a:r>
+              <a:rPr lang="en-US" sz="1500" dirty="0">
+                <a:solidFill>
+                  <a:srgbClr val="3B2A5C"/>
+                </a:solidFill>
+                <a:latin typeface="Calibri" pitchFamily="34" charset="0"/>
+                <a:ea typeface="Calibri" pitchFamily="34" charset="-122"/>
+                <a:cs typeface="Calibri" pitchFamily="34" charset="-120"/>
+              </a:rPr>
+              <a:t>Jangan ubah susunan, qty, atau tinggi rak</a:t>
+            </a:r>
+            <a:endParaRPr lang="en-US" sz="1500" dirty="0"/>
+          </a:p>
+          <a:p>
+            <a:pPr marL="342900" indent="-342900">
+              <a:spcAft>
+                <a:spcPts val="800"/>
+              </a:spcAft>
+              <a:buSzPct val="100000"/>
+              <a:buChar char="•"/>
+            </a:pPr>
+            <a:r>
+              <a:rPr lang="en-US" sz="1500" dirty="0">
+                <a:solidFill>
+                  <a:srgbClr val="3B2A5C"/>
+                </a:solidFill>
+                <a:latin typeface="Calibri" pitchFamily="34" charset="0"/>
+                <a:ea typeface="Calibri" pitchFamily="34" charset="-122"/>
+                <a:cs typeface="Calibri" pitchFamily="34" charset="-120"/>
+              </a:rPr>
+              <a:t>Jangan jual unit sampel yang sudah dibuka sebagai produk baru</a:t>
+            </a:r>
+            <a:endParaRPr lang="en-US" sz="1500" dirty="0"/>
+          </a:p>
+          <a:p>
+            <a:pPr marL="342900" indent="-342900">
+              <a:spcAft>
+                <a:spcPts val="800"/>
+              </a:spcAft>
+              <a:buSzPct val="100000"/>
+              <a:buChar char="•"/>
+            </a:pPr>
+            <a:r>
+              <a:rPr lang="en-US" sz="1500" dirty="0">
+                <a:solidFill>
+                  <a:srgbClr val="3B2A5C"/>
+                </a:solidFill>
+                <a:latin typeface="Calibri" pitchFamily="34" charset="0"/>
+                <a:ea typeface="Calibri" pitchFamily="34" charset="-122"/>
+                <a:cs typeface="Calibri" pitchFamily="34" charset="-120"/>
+              </a:rPr>
+              <a:t>Jangan cetak POP sementara selain di percetakan</a:t>
+            </a:r>
+            <a:endParaRPr lang="en-US" sz="1500" dirty="0"/>
+          </a:p>
+        </p:txBody>
+      </p:sp>
+    </p:spTree>
+  </p:cSld>
+  <p:clrMapOvr>
+    <a:masterClrMapping/>
+  </p:clrMapOvr>
+</p:sld>
+</file>
+
+<file path=ppt/slides/slide11.xml><?xml version="1.0" encoding="utf-8"?>
+<p:sld xmlns:a="http://schemas.openxmlformats.org/drawingml/2006/main" xmlns:r="http://schemas.openxmlformats.org/officeDocument/2006/relationships" xmlns:p="http://schemas.openxmlformats.org/presentationml/2006/main">
+  <p:cSld name="Slide 11">
+    <p:bg>
+      <p:bgPr>
+        <a:solidFill>
           <a:srgbClr val="3B2A5C"/>
         </a:solidFill>
       </p:bgPr>
@@ -2511,7 +3234,7 @@
                 <a:ea typeface="Calibri" pitchFamily="34" charset="-122"/>
                 <a:cs typeface="Calibri" pitchFamily="34" charset="-120"/>
               </a:rPr>
-              <a:t>6 warna dibuka sebagai sampel, Secret tetap tersegel</a:t>
+              <a:t>Buka 1 PDQ SMALL + 1 PDQ LARGE sesuai video MD, display 6 warna (5 bila Secret diamankan)</a:t>
             </a:r>
             <a:endParaRPr lang="en-US" sz="1600" dirty="0"/>
           </a:p>
@@ -2877,6 +3600,136 @@
         <p:spPr>
           <a:xfrm>
             <a:off x="1325880" y="5276088"/>
+            <a:ext cx="10149840" cy="548640"/>
+          </a:xfrm>
+          <a:prstGeom prst="rect">
+            <a:avLst/>
+          </a:prstGeom>
+          <a:noFill/>
+          <a:ln/>
+        </p:spPr>
+        <p:txBody>
+          <a:bodyPr wrap="square" lIns="0" tIns="0" rIns="0" bIns="0" rtlCol="0" anchor="ctr"/>
+          <a:lstStyle/>
+          <a:p>
+            <a:pPr indent="0" marL="0">
+              <a:buNone/>
+            </a:pPr>
+            <a:r>
+              <a:rPr lang="en-US" sz="1600" dirty="0">
+                <a:solidFill>
+                  <a:srgbClr val="FFFFFF"/>
+                </a:solidFill>
+                <a:latin typeface="Calibri" pitchFamily="34" charset="0"/>
+                <a:ea typeface="Calibri" pitchFamily="34" charset="-122"/>
+                <a:cs typeface="Calibri" pitchFamily="34" charset="-120"/>
+              </a:rPr>
+              <a:t>Kardus display dibuka pelan-pelan, struktur kardus tidak rusak</a:t>
+            </a:r>
+            <a:endParaRPr lang="en-US" sz="1600" dirty="0"/>
+          </a:p>
+        </p:txBody>
+      </p:sp>
+      <p:sp>
+        <p:nvSpPr>
+          <p:cNvPr id="31" name="Shape 29"/>
+          <p:cNvSpPr/>
+          <p:nvPr/>
+        </p:nvSpPr>
+        <p:spPr>
+          <a:xfrm>
+            <a:off x="548640" y="5934456"/>
+            <a:ext cx="11064240" cy="548640"/>
+          </a:xfrm>
+          <a:prstGeom prst="roundRect">
+            <a:avLst>
+              <a:gd name="adj" fmla="val 20000"/>
+            </a:avLst>
+          </a:prstGeom>
+          <a:solidFill>
+            <a:srgbClr val="4D3B73"/>
+          </a:solidFill>
+          <a:ln w="12700">
+            <a:solidFill>
+              <a:srgbClr val="4D3B73"/>
+            </a:solidFill>
+            <a:prstDash val="solid"/>
+          </a:ln>
+        </p:spPr>
+      </p:sp>
+      <p:sp>
+        <p:nvSpPr>
+          <p:cNvPr id="32" name="Shape 30"/>
+          <p:cNvSpPr/>
+          <p:nvPr/>
+        </p:nvSpPr>
+        <p:spPr>
+          <a:xfrm>
+            <a:off x="731520" y="6025896"/>
+            <a:ext cx="365760" cy="365760"/>
+          </a:xfrm>
+          <a:prstGeom prst="ellipse">
+            <a:avLst/>
+          </a:prstGeom>
+          <a:solidFill>
+            <a:srgbClr val="FDE68A"/>
+          </a:solidFill>
+          <a:ln w="12700">
+            <a:solidFill>
+              <a:srgbClr val="FDE68A"/>
+            </a:solidFill>
+            <a:prstDash val="solid"/>
+          </a:ln>
+        </p:spPr>
+      </p:sp>
+      <p:sp>
+        <p:nvSpPr>
+          <p:cNvPr id="33" name="Text 31"/>
+          <p:cNvSpPr txBox="1"/>
+          <p:nvPr/>
+        </p:nvSpPr>
+        <p:spPr>
+          <a:xfrm>
+            <a:off x="731520" y="6025896"/>
+            <a:ext cx="365760" cy="365760"/>
+          </a:xfrm>
+          <a:prstGeom prst="rect">
+            <a:avLst/>
+          </a:prstGeom>
+          <a:noFill/>
+          <a:ln/>
+        </p:spPr>
+        <p:txBody>
+          <a:bodyPr wrap="square" lIns="0" tIns="0" rIns="0" bIns="0" rtlCol="0" anchor="ctr"/>
+          <a:lstStyle/>
+          <a:p>
+            <a:pPr algn="ctr" indent="0" marL="0">
+              <a:buNone/>
+            </a:pPr>
+            <a:r>
+              <a:rPr lang="en-US" sz="1600" b="1" dirty="0">
+                <a:solidFill>
+                  <a:srgbClr val="3B2A5C"/>
+                </a:solidFill>
+                <a:latin typeface="Calibri" pitchFamily="34" charset="0"/>
+                <a:ea typeface="Calibri" pitchFamily="34" charset="-122"/>
+                <a:cs typeface="Calibri" pitchFamily="34" charset="-120"/>
+              </a:rPr>
+              <a:t>✓</a:t>
+            </a:r>
+            <a:endParaRPr lang="en-US" sz="1600" dirty="0"/>
+          </a:p>
+        </p:txBody>
+      </p:sp>
+      <p:sp>
+        <p:nvSpPr>
+          <p:cNvPr id="34" name="Text 32"/>
+          <p:cNvSpPr txBox="1"/>
+          <p:nvPr/>
+        </p:nvSpPr>
+        <p:spPr>
+          <a:xfrm>
+            <a:off x="1325880" y="5934456"/>
             <a:ext cx="10149840" cy="548640"/>
           </a:xfrm>
           <a:prstGeom prst="rect">
@@ -3856,7 +4709,7 @@
                 <a:ea typeface="Calibri" pitchFamily="34" charset="-122"/>
                 <a:cs typeface="Calibri" pitchFamily="34" charset="-120"/>
               </a:rPr>
-              <a:t>Blind Box dibuka dan didisplay dalam 6 warna, selain warna Secret.</a:t>
+              <a:t>Buka 1 PDQ SMALL dan 1 PDQ LARGE, display 6 warna (5 bila dapat Secret).</a:t>
             </a:r>
             <a:endParaRPr lang="en-US" sz="1600" dirty="0"/>
           </a:p>
@@ -4104,7 +4957,7 @@
       </p:sp>
       <p:pic>
         <p:nvPicPr>
-          <p:cNvPr id="3" name="Image 0" descr="/tmp/claude-0/-home-user-Testing-Erie/31a86cd2-3938-53d6-901f-33e16b329622/scratchpad/w/mock3d.png">    </p:cNvPr>
+          <p:cNvPr id="3" name="Image 0" descr="/tmp/claude-0/-home-user-Testing-Erie/31a86cd2-3938-53d6-901f-33e16b329622/scratchpad/w/mock3d_new.png">    </p:cNvPr>
           <p:cNvPicPr>
             <a:picLocks noChangeAspect="1"/>
           </p:cNvPicPr>
@@ -4118,8 +4971,8 @@
         </p:blipFill>
         <p:spPr>
           <a:xfrm>
-            <a:off x="731520" y="1097280"/>
-            <a:ext cx="4937760" cy="5556879"/>
+            <a:off x="1280160" y="1097280"/>
+            <a:ext cx="3154680" cy="5135912"/>
           </a:xfrm>
           <a:prstGeom prst="rect">
             <a:avLst/>
@@ -4360,7 +5213,7 @@
                 <a:ea typeface="Calibri" pitchFamily="34" charset="-122"/>
                 <a:cs typeface="Calibri" pitchFamily="34" charset="-120"/>
               </a:rPr>
-              <a:t>6 botol warna terbuka sebagai display produk, tanpa Secret.</a:t>
+              <a:t>6 warna terbuka sebagai display (5 warna bila dapat Secret).</a:t>
             </a:r>
             <a:endParaRPr lang="en-US" sz="1800" dirty="0"/>
           </a:p>
@@ -20720,6 +21573,925 @@
                 <a:ea typeface="Cambria" pitchFamily="34" charset="-122"/>
                 <a:cs typeface="Cambria" pitchFamily="34" charset="-120"/>
               </a:rPr>
+              <a:t>Cara membuka produk untuk display</a:t>
+            </a:r>
+            <a:endParaRPr lang="en-US" sz="3600" dirty="0"/>
+          </a:p>
+        </p:txBody>
+      </p:sp>
+      <p:sp>
+        <p:nvSpPr>
+          <p:cNvPr id="3" name="Text 1"/>
+          <p:cNvSpPr txBox="1"/>
+          <p:nvPr/>
+        </p:nvSpPr>
+        <p:spPr>
+          <a:xfrm>
+            <a:off x="548640" y="1051560"/>
+            <a:ext cx="11064240" cy="365760"/>
+          </a:xfrm>
+          <a:prstGeom prst="rect">
+            <a:avLst/>
+          </a:prstGeom>
+          <a:noFill/>
+          <a:ln/>
+        </p:spPr>
+        <p:txBody>
+          <a:bodyPr wrap="square" lIns="0" tIns="0" rIns="0" bIns="0" rtlCol="0" anchor="ctr"/>
+          <a:lstStyle/>
+          <a:p>
+            <a:pPr indent="0" marL="0">
+              <a:buNone/>
+            </a:pPr>
+            <a:r>
+              <a:rPr lang="en-US" sz="1600" dirty="0">
+                <a:solidFill>
+                  <a:srgbClr val="6B6580"/>
+                </a:solidFill>
+                <a:latin typeface="Calibri" pitchFamily="34" charset="0"/>
+                <a:ea typeface="Calibri" pitchFamily="34" charset="-122"/>
+                <a:cs typeface="Calibri" pitchFamily="34" charset="-120"/>
+              </a:rPr>
+              <a:t>Berlaku untuk sampel display di endcap Thermal</a:t>
+            </a:r>
+            <a:endParaRPr lang="en-US" sz="1600" dirty="0"/>
+          </a:p>
+        </p:txBody>
+      </p:sp>
+      <p:sp>
+        <p:nvSpPr>
+          <p:cNvPr id="4" name="Shape 2"/>
+          <p:cNvSpPr/>
+          <p:nvPr/>
+        </p:nvSpPr>
+        <p:spPr>
+          <a:xfrm>
+            <a:off x="548640" y="1737360"/>
+            <a:ext cx="2651760" cy="3017520"/>
+          </a:xfrm>
+          <a:prstGeom prst="roundRect">
+            <a:avLst>
+              <a:gd name="adj" fmla="val 5172"/>
+            </a:avLst>
+          </a:prstGeom>
+          <a:solidFill>
+            <a:srgbClr val="E3F6FB"/>
+          </a:solidFill>
+          <a:ln w="12700">
+            <a:solidFill>
+              <a:srgbClr val="E3F6FB"/>
+            </a:solidFill>
+            <a:prstDash val="solid"/>
+          </a:ln>
+        </p:spPr>
+      </p:sp>
+      <p:sp>
+        <p:nvSpPr>
+          <p:cNvPr id="5" name="Shape 3"/>
+          <p:cNvSpPr/>
+          <p:nvPr/>
+        </p:nvSpPr>
+        <p:spPr>
+          <a:xfrm>
+            <a:off x="777240" y="1965960"/>
+            <a:ext cx="640080" cy="640080"/>
+          </a:xfrm>
+          <a:prstGeom prst="ellipse">
+            <a:avLst/>
+          </a:prstGeom>
+          <a:solidFill>
+            <a:srgbClr val="4DC3E0"/>
+          </a:solidFill>
+          <a:ln w="12700">
+            <a:solidFill>
+              <a:srgbClr val="4DC3E0"/>
+            </a:solidFill>
+            <a:prstDash val="solid"/>
+          </a:ln>
+        </p:spPr>
+      </p:sp>
+      <p:sp>
+        <p:nvSpPr>
+          <p:cNvPr id="6" name="Text 4"/>
+          <p:cNvSpPr txBox="1"/>
+          <p:nvPr/>
+        </p:nvSpPr>
+        <p:spPr>
+          <a:xfrm>
+            <a:off x="777240" y="1965960"/>
+            <a:ext cx="640080" cy="640080"/>
+          </a:xfrm>
+          <a:prstGeom prst="rect">
+            <a:avLst/>
+          </a:prstGeom>
+          <a:noFill/>
+          <a:ln/>
+        </p:spPr>
+        <p:txBody>
+          <a:bodyPr wrap="square" lIns="0" tIns="0" rIns="0" bIns="0" rtlCol="0" anchor="ctr"/>
+          <a:lstStyle/>
+          <a:p>
+            <a:pPr algn="ctr" indent="0" marL="0">
+              <a:buNone/>
+            </a:pPr>
+            <a:r>
+              <a:rPr lang="en-US" sz="2400" b="1" dirty="0">
+                <a:solidFill>
+                  <a:srgbClr val="FFFFFF"/>
+                </a:solidFill>
+                <a:latin typeface="Calibri" pitchFamily="34" charset="0"/>
+                <a:ea typeface="Calibri" pitchFamily="34" charset="-122"/>
+                <a:cs typeface="Calibri" pitchFamily="34" charset="-120"/>
+              </a:rPr>
+              <a:t>1</a:t>
+            </a:r>
+            <a:endParaRPr lang="en-US" sz="2400" dirty="0"/>
+          </a:p>
+        </p:txBody>
+      </p:sp>
+      <p:sp>
+        <p:nvSpPr>
+          <p:cNvPr id="7" name="Text 5"/>
+          <p:cNvSpPr txBox="1"/>
+          <p:nvPr/>
+        </p:nvSpPr>
+        <p:spPr>
+          <a:xfrm>
+            <a:off x="777240" y="2788920"/>
+            <a:ext cx="2194560" cy="457200"/>
+          </a:xfrm>
+          <a:prstGeom prst="rect">
+            <a:avLst/>
+          </a:prstGeom>
+          <a:noFill/>
+          <a:ln/>
+        </p:spPr>
+        <p:txBody>
+          <a:bodyPr wrap="square" lIns="0" tIns="0" rIns="0" bIns="0" rtlCol="0" anchor="ctr"/>
+          <a:lstStyle/>
+          <a:p>
+            <a:pPr indent="0" marL="0">
+              <a:buNone/>
+            </a:pPr>
+            <a:r>
+              <a:rPr lang="en-US" sz="2000" b="1" dirty="0">
+                <a:solidFill>
+                  <a:srgbClr val="3B2A5C"/>
+                </a:solidFill>
+                <a:latin typeface="Calibri" pitchFamily="34" charset="0"/>
+                <a:ea typeface="Calibri" pitchFamily="34" charset="-122"/>
+                <a:cs typeface="Calibri" pitchFamily="34" charset="-120"/>
+              </a:rPr>
+              <a:t>Ambil PDQ</a:t>
+            </a:r>
+            <a:endParaRPr lang="en-US" sz="2000" dirty="0"/>
+          </a:p>
+        </p:txBody>
+      </p:sp>
+      <p:sp>
+        <p:nvSpPr>
+          <p:cNvPr id="8" name="Text 6"/>
+          <p:cNvSpPr txBox="1"/>
+          <p:nvPr/>
+        </p:nvSpPr>
+        <p:spPr>
+          <a:xfrm>
+            <a:off x="777240" y="3291840"/>
+            <a:ext cx="2240280" cy="1371600"/>
+          </a:xfrm>
+          <a:prstGeom prst="rect">
+            <a:avLst/>
+          </a:prstGeom>
+          <a:noFill/>
+          <a:ln/>
+        </p:spPr>
+        <p:txBody>
+          <a:bodyPr wrap="square" lIns="0" tIns="0" rIns="0" bIns="0" rtlCol="0" anchor="t"/>
+          <a:lstStyle/>
+          <a:p>
+            <a:pPr indent="0" marL="0">
+              <a:buNone/>
+            </a:pPr>
+            <a:r>
+              <a:rPr lang="en-US" sz="1500" dirty="0">
+                <a:solidFill>
+                  <a:srgbClr val="3B2A5C"/>
+                </a:solidFill>
+                <a:latin typeface="Calibri" pitchFamily="34" charset="0"/>
+                <a:ea typeface="Calibri" pitchFamily="34" charset="-122"/>
+                <a:cs typeface="Calibri" pitchFamily="34" charset="-120"/>
+              </a:rPr>
+              <a:t>Ambil 1 PDQ untuk SKU SMALL dan 1 PDQ untuk SKU LARGE.</a:t>
+            </a:r>
+            <a:endParaRPr lang="en-US" sz="1500" dirty="0"/>
+          </a:p>
+        </p:txBody>
+      </p:sp>
+      <p:sp>
+        <p:nvSpPr>
+          <p:cNvPr id="9" name="Shape 7"/>
+          <p:cNvSpPr/>
+          <p:nvPr/>
+        </p:nvSpPr>
+        <p:spPr>
+          <a:xfrm>
+            <a:off x="3383280" y="1737360"/>
+            <a:ext cx="2651760" cy="3017520"/>
+          </a:xfrm>
+          <a:prstGeom prst="roundRect">
+            <a:avLst>
+              <a:gd name="adj" fmla="val 5172"/>
+            </a:avLst>
+          </a:prstGeom>
+          <a:solidFill>
+            <a:srgbClr val="FDEAF3"/>
+          </a:solidFill>
+          <a:ln w="12700">
+            <a:solidFill>
+              <a:srgbClr val="FDEAF3"/>
+            </a:solidFill>
+            <a:prstDash val="solid"/>
+          </a:ln>
+        </p:spPr>
+      </p:sp>
+      <p:sp>
+        <p:nvSpPr>
+          <p:cNvPr id="10" name="Shape 8"/>
+          <p:cNvSpPr/>
+          <p:nvPr/>
+        </p:nvSpPr>
+        <p:spPr>
+          <a:xfrm>
+            <a:off x="3611880" y="1965960"/>
+            <a:ext cx="640080" cy="640080"/>
+          </a:xfrm>
+          <a:prstGeom prst="ellipse">
+            <a:avLst/>
+          </a:prstGeom>
+          <a:solidFill>
+            <a:srgbClr val="F27BB0"/>
+          </a:solidFill>
+          <a:ln w="12700">
+            <a:solidFill>
+              <a:srgbClr val="F27BB0"/>
+            </a:solidFill>
+            <a:prstDash val="solid"/>
+          </a:ln>
+        </p:spPr>
+      </p:sp>
+      <p:sp>
+        <p:nvSpPr>
+          <p:cNvPr id="11" name="Text 9"/>
+          <p:cNvSpPr txBox="1"/>
+          <p:nvPr/>
+        </p:nvSpPr>
+        <p:spPr>
+          <a:xfrm>
+            <a:off x="3611880" y="1965960"/>
+            <a:ext cx="640080" cy="640080"/>
+          </a:xfrm>
+          <a:prstGeom prst="rect">
+            <a:avLst/>
+          </a:prstGeom>
+          <a:noFill/>
+          <a:ln/>
+        </p:spPr>
+        <p:txBody>
+          <a:bodyPr wrap="square" lIns="0" tIns="0" rIns="0" bIns="0" rtlCol="0" anchor="ctr"/>
+          <a:lstStyle/>
+          <a:p>
+            <a:pPr algn="ctr" indent="0" marL="0">
+              <a:buNone/>
+            </a:pPr>
+            <a:r>
+              <a:rPr lang="en-US" sz="2400" b="1" dirty="0">
+                <a:solidFill>
+                  <a:srgbClr val="FFFFFF"/>
+                </a:solidFill>
+                <a:latin typeface="Calibri" pitchFamily="34" charset="0"/>
+                <a:ea typeface="Calibri" pitchFamily="34" charset="-122"/>
+                <a:cs typeface="Calibri" pitchFamily="34" charset="-120"/>
+              </a:rPr>
+              <a:t>2</a:t>
+            </a:r>
+            <a:endParaRPr lang="en-US" sz="2400" dirty="0"/>
+          </a:p>
+        </p:txBody>
+      </p:sp>
+      <p:sp>
+        <p:nvSpPr>
+          <p:cNvPr id="12" name="Text 10"/>
+          <p:cNvSpPr txBox="1"/>
+          <p:nvPr/>
+        </p:nvSpPr>
+        <p:spPr>
+          <a:xfrm>
+            <a:off x="3611880" y="2788920"/>
+            <a:ext cx="2194560" cy="457200"/>
+          </a:xfrm>
+          <a:prstGeom prst="rect">
+            <a:avLst/>
+          </a:prstGeom>
+          <a:noFill/>
+          <a:ln/>
+        </p:spPr>
+        <p:txBody>
+          <a:bodyPr wrap="square" lIns="0" tIns="0" rIns="0" bIns="0" rtlCol="0" anchor="ctr"/>
+          <a:lstStyle/>
+          <a:p>
+            <a:pPr indent="0" marL="0">
+              <a:buNone/>
+            </a:pPr>
+            <a:r>
+              <a:rPr lang="en-US" sz="2000" b="1" dirty="0">
+                <a:solidFill>
+                  <a:srgbClr val="3B2A5C"/>
+                </a:solidFill>
+                <a:latin typeface="Calibri" pitchFamily="34" charset="0"/>
+                <a:ea typeface="Calibri" pitchFamily="34" charset="-122"/>
+                <a:cs typeface="Calibri" pitchFamily="34" charset="-120"/>
+              </a:rPr>
+              <a:t>Buka pelan-pelan</a:t>
+            </a:r>
+            <a:endParaRPr lang="en-US" sz="2000" dirty="0"/>
+          </a:p>
+        </p:txBody>
+      </p:sp>
+      <p:sp>
+        <p:nvSpPr>
+          <p:cNvPr id="13" name="Text 11"/>
+          <p:cNvSpPr txBox="1"/>
+          <p:nvPr/>
+        </p:nvSpPr>
+        <p:spPr>
+          <a:xfrm>
+            <a:off x="3611880" y="3291840"/>
+            <a:ext cx="2240280" cy="1371600"/>
+          </a:xfrm>
+          <a:prstGeom prst="rect">
+            <a:avLst/>
+          </a:prstGeom>
+          <a:noFill/>
+          <a:ln/>
+        </p:spPr>
+        <p:txBody>
+          <a:bodyPr wrap="square" lIns="0" tIns="0" rIns="0" bIns="0" rtlCol="0" anchor="t"/>
+          <a:lstStyle/>
+          <a:p>
+            <a:pPr indent="0" marL="0">
+              <a:buNone/>
+            </a:pPr>
+            <a:r>
+              <a:rPr lang="en-US" sz="1500" dirty="0">
+                <a:solidFill>
+                  <a:srgbClr val="3B2A5C"/>
+                </a:solidFill>
+                <a:latin typeface="Calibri" pitchFamily="34" charset="0"/>
+                <a:ea typeface="Calibri" pitchFamily="34" charset="-122"/>
+                <a:cs typeface="Calibri" pitchFamily="34" charset="-120"/>
+              </a:rPr>
+              <a:t>Buka kardus display dengan hati-hati agar struktur kardus tidak rusak.</a:t>
+            </a:r>
+            <a:endParaRPr lang="en-US" sz="1500" dirty="0"/>
+          </a:p>
+        </p:txBody>
+      </p:sp>
+      <p:sp>
+        <p:nvSpPr>
+          <p:cNvPr id="14" name="Shape 12"/>
+          <p:cNvSpPr/>
+          <p:nvPr/>
+        </p:nvSpPr>
+        <p:spPr>
+          <a:xfrm>
+            <a:off x="6217920" y="1737360"/>
+            <a:ext cx="2651760" cy="3017520"/>
+          </a:xfrm>
+          <a:prstGeom prst="roundRect">
+            <a:avLst>
+              <a:gd name="adj" fmla="val 5172"/>
+            </a:avLst>
+          </a:prstGeom>
+          <a:solidFill>
+            <a:srgbClr val="E3F6FB"/>
+          </a:solidFill>
+          <a:ln w="12700">
+            <a:solidFill>
+              <a:srgbClr val="E3F6FB"/>
+            </a:solidFill>
+            <a:prstDash val="solid"/>
+          </a:ln>
+        </p:spPr>
+      </p:sp>
+      <p:sp>
+        <p:nvSpPr>
+          <p:cNvPr id="15" name="Shape 13"/>
+          <p:cNvSpPr/>
+          <p:nvPr/>
+        </p:nvSpPr>
+        <p:spPr>
+          <a:xfrm>
+            <a:off x="6446520" y="1965960"/>
+            <a:ext cx="640080" cy="640080"/>
+          </a:xfrm>
+          <a:prstGeom prst="ellipse">
+            <a:avLst/>
+          </a:prstGeom>
+          <a:solidFill>
+            <a:srgbClr val="4DC3E0"/>
+          </a:solidFill>
+          <a:ln w="12700">
+            <a:solidFill>
+              <a:srgbClr val="4DC3E0"/>
+            </a:solidFill>
+            <a:prstDash val="solid"/>
+          </a:ln>
+        </p:spPr>
+      </p:sp>
+      <p:sp>
+        <p:nvSpPr>
+          <p:cNvPr id="16" name="Text 14"/>
+          <p:cNvSpPr txBox="1"/>
+          <p:nvPr/>
+        </p:nvSpPr>
+        <p:spPr>
+          <a:xfrm>
+            <a:off x="6446520" y="1965960"/>
+            <a:ext cx="640080" cy="640080"/>
+          </a:xfrm>
+          <a:prstGeom prst="rect">
+            <a:avLst/>
+          </a:prstGeom>
+          <a:noFill/>
+          <a:ln/>
+        </p:spPr>
+        <p:txBody>
+          <a:bodyPr wrap="square" lIns="0" tIns="0" rIns="0" bIns="0" rtlCol="0" anchor="ctr"/>
+          <a:lstStyle/>
+          <a:p>
+            <a:pPr algn="ctr" indent="0" marL="0">
+              <a:buNone/>
+            </a:pPr>
+            <a:r>
+              <a:rPr lang="en-US" sz="2400" b="1" dirty="0">
+                <a:solidFill>
+                  <a:srgbClr val="FFFFFF"/>
+                </a:solidFill>
+                <a:latin typeface="Calibri" pitchFamily="34" charset="0"/>
+                <a:ea typeface="Calibri" pitchFamily="34" charset="-122"/>
+                <a:cs typeface="Calibri" pitchFamily="34" charset="-120"/>
+              </a:rPr>
+              <a:t>3</a:t>
+            </a:r>
+            <a:endParaRPr lang="en-US" sz="2400" dirty="0"/>
+          </a:p>
+        </p:txBody>
+      </p:sp>
+      <p:sp>
+        <p:nvSpPr>
+          <p:cNvPr id="17" name="Text 15"/>
+          <p:cNvSpPr txBox="1"/>
+          <p:nvPr/>
+        </p:nvSpPr>
+        <p:spPr>
+          <a:xfrm>
+            <a:off x="6446520" y="2788920"/>
+            <a:ext cx="2194560" cy="457200"/>
+          </a:xfrm>
+          <a:prstGeom prst="rect">
+            <a:avLst/>
+          </a:prstGeom>
+          <a:noFill/>
+          <a:ln/>
+        </p:spPr>
+        <p:txBody>
+          <a:bodyPr wrap="square" lIns="0" tIns="0" rIns="0" bIns="0" rtlCol="0" anchor="ctr"/>
+          <a:lstStyle/>
+          <a:p>
+            <a:pPr indent="0" marL="0">
+              <a:buNone/>
+            </a:pPr>
+            <a:r>
+              <a:rPr lang="en-US" sz="2000" b="1" dirty="0">
+                <a:solidFill>
+                  <a:srgbClr val="3B2A5C"/>
+                </a:solidFill>
+                <a:latin typeface="Calibri" pitchFamily="34" charset="0"/>
+                <a:ea typeface="Calibri" pitchFamily="34" charset="-122"/>
+                <a:cs typeface="Calibri" pitchFamily="34" charset="-120"/>
+              </a:rPr>
+              <a:t>Cek warna</a:t>
+            </a:r>
+            <a:endParaRPr lang="en-US" sz="2000" dirty="0"/>
+          </a:p>
+        </p:txBody>
+      </p:sp>
+      <p:sp>
+        <p:nvSpPr>
+          <p:cNvPr id="18" name="Text 16"/>
+          <p:cNvSpPr txBox="1"/>
+          <p:nvPr/>
+        </p:nvSpPr>
+        <p:spPr>
+          <a:xfrm>
+            <a:off x="6446520" y="3291840"/>
+            <a:ext cx="2240280" cy="1371600"/>
+          </a:xfrm>
+          <a:prstGeom prst="rect">
+            <a:avLst/>
+          </a:prstGeom>
+          <a:noFill/>
+          <a:ln/>
+        </p:spPr>
+        <p:txBody>
+          <a:bodyPr wrap="square" lIns="0" tIns="0" rIns="0" bIns="0" rtlCol="0" anchor="t"/>
+          <a:lstStyle/>
+          <a:p>
+            <a:pPr indent="0" marL="0">
+              <a:buNone/>
+            </a:pPr>
+            <a:r>
+              <a:rPr lang="en-US" sz="1500" dirty="0">
+                <a:solidFill>
+                  <a:srgbClr val="3B2A5C"/>
+                </a:solidFill>
+                <a:latin typeface="Calibri" pitchFamily="34" charset="0"/>
+                <a:ea typeface="Calibri" pitchFamily="34" charset="-122"/>
+                <a:cs typeface="Calibri" pitchFamily="34" charset="-120"/>
+              </a:rPr>
+              <a:t>Dalam 1 PDQ warna pasti berbeda, tetapi ada kemungkinan dapat Secret.</a:t>
+            </a:r>
+            <a:endParaRPr lang="en-US" sz="1500" dirty="0"/>
+          </a:p>
+        </p:txBody>
+      </p:sp>
+      <p:sp>
+        <p:nvSpPr>
+          <p:cNvPr id="19" name="Shape 17"/>
+          <p:cNvSpPr/>
+          <p:nvPr/>
+        </p:nvSpPr>
+        <p:spPr>
+          <a:xfrm>
+            <a:off x="9052560" y="1737360"/>
+            <a:ext cx="2651760" cy="3017520"/>
+          </a:xfrm>
+          <a:prstGeom prst="roundRect">
+            <a:avLst>
+              <a:gd name="adj" fmla="val 5172"/>
+            </a:avLst>
+          </a:prstGeom>
+          <a:solidFill>
+            <a:srgbClr val="FDEAF3"/>
+          </a:solidFill>
+          <a:ln w="12700">
+            <a:solidFill>
+              <a:srgbClr val="FDEAF3"/>
+            </a:solidFill>
+            <a:prstDash val="solid"/>
+          </a:ln>
+        </p:spPr>
+      </p:sp>
+      <p:sp>
+        <p:nvSpPr>
+          <p:cNvPr id="20" name="Shape 18"/>
+          <p:cNvSpPr/>
+          <p:nvPr/>
+        </p:nvSpPr>
+        <p:spPr>
+          <a:xfrm>
+            <a:off x="9281160" y="1965960"/>
+            <a:ext cx="640080" cy="640080"/>
+          </a:xfrm>
+          <a:prstGeom prst="ellipse">
+            <a:avLst/>
+          </a:prstGeom>
+          <a:solidFill>
+            <a:srgbClr val="F27BB0"/>
+          </a:solidFill>
+          <a:ln w="12700">
+            <a:solidFill>
+              <a:srgbClr val="F27BB0"/>
+            </a:solidFill>
+            <a:prstDash val="solid"/>
+          </a:ln>
+        </p:spPr>
+      </p:sp>
+      <p:sp>
+        <p:nvSpPr>
+          <p:cNvPr id="21" name="Text 19"/>
+          <p:cNvSpPr txBox="1"/>
+          <p:nvPr/>
+        </p:nvSpPr>
+        <p:spPr>
+          <a:xfrm>
+            <a:off x="9281160" y="1965960"/>
+            <a:ext cx="640080" cy="640080"/>
+          </a:xfrm>
+          <a:prstGeom prst="rect">
+            <a:avLst/>
+          </a:prstGeom>
+          <a:noFill/>
+          <a:ln/>
+        </p:spPr>
+        <p:txBody>
+          <a:bodyPr wrap="square" lIns="0" tIns="0" rIns="0" bIns="0" rtlCol="0" anchor="ctr"/>
+          <a:lstStyle/>
+          <a:p>
+            <a:pPr algn="ctr" indent="0" marL="0">
+              <a:buNone/>
+            </a:pPr>
+            <a:r>
+              <a:rPr lang="en-US" sz="2400" b="1" dirty="0">
+                <a:solidFill>
+                  <a:srgbClr val="FFFFFF"/>
+                </a:solidFill>
+                <a:latin typeface="Calibri" pitchFamily="34" charset="0"/>
+                <a:ea typeface="Calibri" pitchFamily="34" charset="-122"/>
+                <a:cs typeface="Calibri" pitchFamily="34" charset="-120"/>
+              </a:rPr>
+              <a:t>4</a:t>
+            </a:r>
+            <a:endParaRPr lang="en-US" sz="2400" dirty="0"/>
+          </a:p>
+        </p:txBody>
+      </p:sp>
+      <p:sp>
+        <p:nvSpPr>
+          <p:cNvPr id="22" name="Text 20"/>
+          <p:cNvSpPr txBox="1"/>
+          <p:nvPr/>
+        </p:nvSpPr>
+        <p:spPr>
+          <a:xfrm>
+            <a:off x="9281160" y="2788920"/>
+            <a:ext cx="2194560" cy="457200"/>
+          </a:xfrm>
+          <a:prstGeom prst="rect">
+            <a:avLst/>
+          </a:prstGeom>
+          <a:noFill/>
+          <a:ln/>
+        </p:spPr>
+        <p:txBody>
+          <a:bodyPr wrap="square" lIns="0" tIns="0" rIns="0" bIns="0" rtlCol="0" anchor="ctr"/>
+          <a:lstStyle/>
+          <a:p>
+            <a:pPr indent="0" marL="0">
+              <a:buNone/>
+            </a:pPr>
+            <a:r>
+              <a:rPr lang="en-US" sz="2000" b="1" dirty="0">
+                <a:solidFill>
+                  <a:srgbClr val="3B2A5C"/>
+                </a:solidFill>
+                <a:latin typeface="Calibri" pitchFamily="34" charset="0"/>
+                <a:ea typeface="Calibri" pitchFamily="34" charset="-122"/>
+                <a:cs typeface="Calibri" pitchFamily="34" charset="-120"/>
+              </a:rPr>
+              <a:t>Display</a:t>
+            </a:r>
+            <a:endParaRPr lang="en-US" sz="2000" dirty="0"/>
+          </a:p>
+        </p:txBody>
+      </p:sp>
+      <p:sp>
+        <p:nvSpPr>
+          <p:cNvPr id="23" name="Text 21"/>
+          <p:cNvSpPr txBox="1"/>
+          <p:nvPr/>
+        </p:nvSpPr>
+        <p:spPr>
+          <a:xfrm>
+            <a:off x="9281160" y="3291840"/>
+            <a:ext cx="2240280" cy="1371600"/>
+          </a:xfrm>
+          <a:prstGeom prst="rect">
+            <a:avLst/>
+          </a:prstGeom>
+          <a:noFill/>
+          <a:ln/>
+        </p:spPr>
+        <p:txBody>
+          <a:bodyPr wrap="square" lIns="0" tIns="0" rIns="0" bIns="0" rtlCol="0" anchor="t"/>
+          <a:lstStyle/>
+          <a:p>
+            <a:pPr indent="0" marL="0">
+              <a:buNone/>
+            </a:pPr>
+            <a:r>
+              <a:rPr lang="en-US" sz="1500" dirty="0">
+                <a:solidFill>
+                  <a:srgbClr val="3B2A5C"/>
+                </a:solidFill>
+                <a:latin typeface="Calibri" pitchFamily="34" charset="0"/>
+                <a:ea typeface="Calibri" pitchFamily="34" charset="-122"/>
+                <a:cs typeface="Calibri" pitchFamily="34" charset="-120"/>
+              </a:rPr>
+              <a:t>Display 6 warna. Jika dapat Secret, amankan dulu dan display 5 warna.</a:t>
+            </a:r>
+            <a:endParaRPr lang="en-US" sz="1500" dirty="0"/>
+          </a:p>
+        </p:txBody>
+      </p:sp>
+      <p:sp>
+        <p:nvSpPr>
+          <p:cNvPr id="24" name="Shape 22"/>
+          <p:cNvSpPr/>
+          <p:nvPr/>
+        </p:nvSpPr>
+        <p:spPr>
+          <a:xfrm>
+            <a:off x="548640" y="5074920"/>
+            <a:ext cx="11064240" cy="1005840"/>
+          </a:xfrm>
+          <a:prstGeom prst="roundRect">
+            <a:avLst>
+              <a:gd name="adj" fmla="val 13636"/>
+            </a:avLst>
+          </a:prstGeom>
+          <a:solidFill>
+            <a:srgbClr val="3B2A5C"/>
+          </a:solidFill>
+          <a:ln w="12700">
+            <a:solidFill>
+              <a:srgbClr val="3B2A5C"/>
+            </a:solidFill>
+            <a:prstDash val="solid"/>
+          </a:ln>
+        </p:spPr>
+      </p:sp>
+      <p:sp>
+        <p:nvSpPr>
+          <p:cNvPr id="25" name="Shape 23"/>
+          <p:cNvSpPr/>
+          <p:nvPr/>
+        </p:nvSpPr>
+        <p:spPr>
+          <a:xfrm>
+            <a:off x="868680" y="5303520"/>
+            <a:ext cx="548640" cy="548640"/>
+          </a:xfrm>
+          <a:prstGeom prst="ellipse">
+            <a:avLst/>
+          </a:prstGeom>
+          <a:solidFill>
+            <a:srgbClr val="FDE68A"/>
+          </a:solidFill>
+          <a:ln w="12700">
+            <a:solidFill>
+              <a:srgbClr val="FDE68A"/>
+            </a:solidFill>
+            <a:prstDash val="solid"/>
+          </a:ln>
+        </p:spPr>
+      </p:sp>
+      <p:sp>
+        <p:nvSpPr>
+          <p:cNvPr id="26" name="Shape 24"/>
+          <p:cNvSpPr/>
+          <p:nvPr/>
+        </p:nvSpPr>
+        <p:spPr>
+          <a:xfrm rot="5400000">
+            <a:off x="1051560" y="5458968"/>
+            <a:ext cx="228600" cy="237744"/>
+          </a:xfrm>
+          <a:prstGeom prst="triangle">
+            <a:avLst/>
+          </a:prstGeom>
+          <a:solidFill>
+            <a:srgbClr val="3B2A5C"/>
+          </a:solidFill>
+          <a:ln w="12700">
+            <a:solidFill>
+              <a:srgbClr val="3B2A5C"/>
+            </a:solidFill>
+            <a:prstDash val="solid"/>
+          </a:ln>
+        </p:spPr>
+      </p:sp>
+      <p:sp>
+        <p:nvSpPr>
+          <p:cNvPr id="27" name="Text 25"/>
+          <p:cNvSpPr txBox="1"/>
+          <p:nvPr/>
+        </p:nvSpPr>
+        <p:spPr>
+          <a:xfrm>
+            <a:off x="1645920" y="5074920"/>
+            <a:ext cx="9692640" cy="1005840"/>
+          </a:xfrm>
+          <a:prstGeom prst="rect">
+            <a:avLst/>
+          </a:prstGeom>
+          <a:noFill/>
+          <a:ln/>
+        </p:spPr>
+        <p:txBody>
+          <a:bodyPr wrap="square" lIns="0" tIns="0" rIns="0" bIns="0" rtlCol="0" anchor="ctr"/>
+          <a:lstStyle/>
+          <a:p>
+            <a:pPr indent="0" marL="0">
+              <a:buNone/>
+            </a:pPr>
+            <a:r>
+              <a:rPr lang="en-US" sz="2000" b="1" dirty="0">
+                <a:solidFill>
+                  <a:srgbClr val="FFFFFF"/>
+                </a:solidFill>
+                <a:latin typeface="Calibri" pitchFamily="34" charset="0"/>
+                <a:ea typeface="Calibri" pitchFamily="34" charset="-122"/>
+                <a:cs typeface="Calibri" pitchFamily="34" charset="-120"/>
+              </a:rPr>
+              <a:t>Ikuti video tutorial membuka produk dari MD</a:t>
+            </a:r>
+            <a:endParaRPr lang="en-US" sz="2000" dirty="0"/>
+          </a:p>
+          <a:p>
+            <a:pPr indent="0" marL="0">
+              <a:buNone/>
+            </a:pPr>
+            <a:r>
+              <a:rPr lang="en-US" sz="1400" dirty="0">
+                <a:solidFill>
+                  <a:srgbClr val="F8C6DE"/>
+                </a:solidFill>
+                <a:latin typeface="Calibri" pitchFamily="34" charset="0"/>
+                <a:ea typeface="Calibri" pitchFamily="34" charset="-122"/>
+                <a:cs typeface="Calibri" pitchFamily="34" charset="-120"/>
+              </a:rPr>
+              <a:t>Video tutorial dikirim oleh tim MD. Ikuti urutan dan cara bukanya.</a:t>
+            </a:r>
+            <a:endParaRPr lang="en-US" sz="2000" dirty="0"/>
+          </a:p>
+        </p:txBody>
+      </p:sp>
+    </p:spTree>
+  </p:cSld>
+  <p:clrMapOvr>
+    <a:masterClrMapping/>
+  </p:clrMapOvr>
+</p:sld>
+</file>
+
+<file path=ppt/slides/slide9.xml><?xml version="1.0" encoding="utf-8"?>
+<p:sld xmlns:a="http://schemas.openxmlformats.org/drawingml/2006/main" xmlns:r="http://schemas.openxmlformats.org/officeDocument/2006/relationships" xmlns:p="http://schemas.openxmlformats.org/presentationml/2006/main">
+  <p:cSld name="Slide 9">
+    <p:bg>
+      <p:bgPr>
+        <a:solidFill>
+          <a:srgbClr val="FFFFFF"/>
+        </a:solidFill>
+      </p:bgPr>
+    </p:bg>
+    <p:spTree>
+      <p:nvGrpSpPr>
+        <p:cNvPr id="1" name=""/>
+        <p:cNvGrpSpPr/>
+        <p:nvPr/>
+      </p:nvGrpSpPr>
+      <p:grpSpPr>
+        <a:xfrm>
+          <a:off x="0" y="0"/>
+          <a:ext cx="0" cy="0"/>
+          <a:chOff x="0" y="0"/>
+          <a:chExt cx="0" cy="0"/>
+        </a:xfrm>
+      </p:grpSpPr>
+      <p:sp>
+        <p:nvSpPr>
+          <p:cNvPr id="2" name="Text 0"/>
+          <p:cNvSpPr txBox="1"/>
+          <p:nvPr/>
+        </p:nvSpPr>
+        <p:spPr>
+          <a:xfrm>
+            <a:off x="548640" y="365760"/>
+            <a:ext cx="11064240" cy="731520"/>
+          </a:xfrm>
+          <a:prstGeom prst="rect">
+            <a:avLst/>
+          </a:prstGeom>
+          <a:noFill/>
+          <a:ln/>
+        </p:spPr>
+        <p:txBody>
+          <a:bodyPr wrap="square" lIns="0" tIns="0" rIns="0" bIns="0" rtlCol="0" anchor="ctr"/>
+          <a:lstStyle/>
+          <a:p>
+            <a:pPr indent="0" marL="0">
+              <a:buNone/>
+            </a:pPr>
+            <a:r>
+              <a:rPr lang="en-US" sz="3600" b="1" dirty="0">
+                <a:solidFill>
+                  <a:srgbClr val="3B2A5C"/>
+                </a:solidFill>
+                <a:latin typeface="Cambria" pitchFamily="34" charset="0"/>
+                <a:ea typeface="Cambria" pitchFamily="34" charset="-122"/>
+                <a:cs typeface="Cambria" pitchFamily="34" charset="-120"/>
+              </a:rPr>
               <a:t>Buka 6 warna, header, dan POP</a:t>
             </a:r>
             <a:endParaRPr lang="en-US" sz="3600" dirty="0"/>
@@ -21221,7 +22993,7 @@
                 <a:ea typeface="Calibri" pitchFamily="34" charset="-122"/>
                 <a:cs typeface="Calibri" pitchFamily="34" charset="-120"/>
               </a:rPr>
-              <a:t>Secret tidak dibuka. Hanya 6 warna lainnya yang didisplay terbuka.</a:t>
+              <a:t>Dapat Secret di dalam PDQ? Amankan dulu, lalu display 5 warna.</a:t>
             </a:r>
             <a:endParaRPr lang="en-US" sz="1500" dirty="0"/>
           </a:p>
@@ -21435,640 +23207,6 @@
               <a:t>Dipakai sampai Media Produk Info dari VM terpasang</a:t>
             </a:r>
             <a:endParaRPr lang="en-US" sz="1400" dirty="0"/>
-          </a:p>
-        </p:txBody>
-      </p:sp>
-    </p:spTree>
-  </p:cSld>
-  <p:clrMapOvr>
-    <a:masterClrMapping/>
-  </p:clrMapOvr>
-</p:sld>
-</file>
-
-<file path=ppt/slides/slide9.xml><?xml version="1.0" encoding="utf-8"?>
-<p:sld xmlns:a="http://schemas.openxmlformats.org/drawingml/2006/main" xmlns:r="http://schemas.openxmlformats.org/officeDocument/2006/relationships" xmlns:p="http://schemas.openxmlformats.org/presentationml/2006/main">
-  <p:cSld name="Slide 9">
-    <p:bg>
-      <p:bgPr>
-        <a:solidFill>
-          <a:srgbClr val="FFFFFF"/>
-        </a:solidFill>
-      </p:bgPr>
-    </p:bg>
-    <p:spTree>
-      <p:nvGrpSpPr>
-        <p:cNvPr id="1" name=""/>
-        <p:cNvGrpSpPr/>
-        <p:nvPr/>
-      </p:nvGrpSpPr>
-      <p:grpSpPr>
-        <a:xfrm>
-          <a:off x="0" y="0"/>
-          <a:ext cx="0" cy="0"/>
-          <a:chOff x="0" y="0"/>
-          <a:chExt cx="0" cy="0"/>
-        </a:xfrm>
-      </p:grpSpPr>
-      <p:sp>
-        <p:nvSpPr>
-          <p:cNvPr id="2" name="Text 0"/>
-          <p:cNvSpPr txBox="1"/>
-          <p:nvPr/>
-        </p:nvSpPr>
-        <p:spPr>
-          <a:xfrm>
-            <a:off x="548640" y="365760"/>
-            <a:ext cx="11064240" cy="731520"/>
-          </a:xfrm>
-          <a:prstGeom prst="rect">
-            <a:avLst/>
-          </a:prstGeom>
-          <a:noFill/>
-          <a:ln/>
-        </p:spPr>
-        <p:txBody>
-          <a:bodyPr wrap="square" lIns="0" tIns="0" rIns="0" bIns="0" rtlCol="0" anchor="ctr"/>
-          <a:lstStyle/>
-          <a:p>
-            <a:pPr indent="0" marL="0">
-              <a:buNone/>
-            </a:pPr>
-            <a:r>
-              <a:rPr lang="en-US" sz="3600" b="1" dirty="0">
-                <a:solidFill>
-                  <a:srgbClr val="3B2A5C"/>
-                </a:solidFill>
-                <a:latin typeface="Cambria" pitchFamily="34" charset="0"/>
-                <a:ea typeface="Cambria" pitchFamily="34" charset="-122"/>
-                <a:cs typeface="Cambria" pitchFamily="34" charset="-120"/>
-              </a:rPr>
-              <a:t>Do dan Don'ts display dan penjualan</a:t>
-            </a:r>
-            <a:endParaRPr lang="en-US" sz="3600" dirty="0"/>
-          </a:p>
-        </p:txBody>
-      </p:sp>
-      <p:sp>
-        <p:nvSpPr>
-          <p:cNvPr id="3" name="Text 1"/>
-          <p:cNvSpPr txBox="1"/>
-          <p:nvPr/>
-        </p:nvSpPr>
-        <p:spPr>
-          <a:xfrm>
-            <a:off x="548640" y="1051560"/>
-            <a:ext cx="11064240" cy="365760"/>
-          </a:xfrm>
-          <a:prstGeom prst="rect">
-            <a:avLst/>
-          </a:prstGeom>
-          <a:noFill/>
-          <a:ln/>
-        </p:spPr>
-        <p:txBody>
-          <a:bodyPr wrap="square" lIns="0" tIns="0" rIns="0" bIns="0" rtlCol="0" anchor="ctr"/>
-          <a:lstStyle/>
-          <a:p>
-            <a:pPr indent="0" marL="0">
-              <a:buNone/>
-            </a:pPr>
-            <a:r>
-              <a:rPr lang="en-US" sz="1600" dirty="0">
-                <a:solidFill>
-                  <a:srgbClr val="6B6580"/>
-                </a:solidFill>
-                <a:latin typeface="Calibri" pitchFamily="34" charset="0"/>
-                <a:ea typeface="Calibri" pitchFamily="34" charset="-122"/>
-                <a:cs typeface="Calibri" pitchFamily="34" charset="-120"/>
-              </a:rPr>
-              <a:t>Rekomendasi untuk tim store</a:t>
-            </a:r>
-            <a:endParaRPr lang="en-US" sz="1600" dirty="0"/>
-          </a:p>
-        </p:txBody>
-      </p:sp>
-      <p:sp>
-        <p:nvSpPr>
-          <p:cNvPr id="4" name="Shape 2"/>
-          <p:cNvSpPr/>
-          <p:nvPr/>
-        </p:nvSpPr>
-        <p:spPr>
-          <a:xfrm>
-            <a:off x="548640" y="1645920"/>
-            <a:ext cx="5349240" cy="4754880"/>
-          </a:xfrm>
-          <a:prstGeom prst="roundRect">
-            <a:avLst>
-              <a:gd name="adj" fmla="val 2885"/>
-            </a:avLst>
-          </a:prstGeom>
-          <a:solidFill>
-            <a:srgbClr val="E3F6FB"/>
-          </a:solidFill>
-          <a:ln w="12700">
-            <a:solidFill>
-              <a:srgbClr val="E3F6FB"/>
-            </a:solidFill>
-            <a:prstDash val="solid"/>
-          </a:ln>
-        </p:spPr>
-      </p:sp>
-      <p:sp>
-        <p:nvSpPr>
-          <p:cNvPr id="5" name="Shape 3"/>
-          <p:cNvSpPr/>
-          <p:nvPr/>
-        </p:nvSpPr>
-        <p:spPr>
-          <a:xfrm>
-            <a:off x="822960" y="1828800"/>
-            <a:ext cx="1371600" cy="457200"/>
-          </a:xfrm>
-          <a:prstGeom prst="roundRect">
-            <a:avLst>
-              <a:gd name="adj" fmla="val 50000"/>
-            </a:avLst>
-          </a:prstGeom>
-          <a:solidFill>
-            <a:srgbClr val="4DC3E0"/>
-          </a:solidFill>
-          <a:ln w="12700">
-            <a:solidFill>
-              <a:srgbClr val="4DC3E0"/>
-            </a:solidFill>
-            <a:prstDash val="solid"/>
-          </a:ln>
-        </p:spPr>
-      </p:sp>
-      <p:sp>
-        <p:nvSpPr>
-          <p:cNvPr id="6" name="Text 4"/>
-          <p:cNvSpPr txBox="1"/>
-          <p:nvPr/>
-        </p:nvSpPr>
-        <p:spPr>
-          <a:xfrm>
-            <a:off x="822960" y="1828800"/>
-            <a:ext cx="1371600" cy="457200"/>
-          </a:xfrm>
-          <a:prstGeom prst="rect">
-            <a:avLst/>
-          </a:prstGeom>
-          <a:noFill/>
-          <a:ln/>
-        </p:spPr>
-        <p:txBody>
-          <a:bodyPr wrap="square" lIns="0" tIns="0" rIns="0" bIns="0" rtlCol="0" anchor="ctr"/>
-          <a:lstStyle/>
-          <a:p>
-            <a:pPr algn="ctr" indent="0" marL="0">
-              <a:buNone/>
-            </a:pPr>
-            <a:r>
-              <a:rPr lang="en-US" sz="1800" b="1" dirty="0">
-                <a:solidFill>
-                  <a:srgbClr val="FFFFFF"/>
-                </a:solidFill>
-                <a:latin typeface="Calibri" pitchFamily="34" charset="0"/>
-                <a:ea typeface="Calibri" pitchFamily="34" charset="-122"/>
-                <a:cs typeface="Calibri" pitchFamily="34" charset="-120"/>
-              </a:rPr>
-              <a:t>DO</a:t>
-            </a:r>
-            <a:endParaRPr lang="en-US" sz="1800" dirty="0"/>
-          </a:p>
-        </p:txBody>
-      </p:sp>
-      <p:sp>
-        <p:nvSpPr>
-          <p:cNvPr id="7" name="Text 5"/>
-          <p:cNvSpPr txBox="1"/>
-          <p:nvPr/>
-        </p:nvSpPr>
-        <p:spPr>
-          <a:xfrm>
-            <a:off x="822960" y="2514600"/>
-            <a:ext cx="4800600" cy="3749040"/>
-          </a:xfrm>
-          <a:prstGeom prst="rect">
-            <a:avLst/>
-          </a:prstGeom>
-          <a:noFill/>
-          <a:ln/>
-        </p:spPr>
-        <p:txBody>
-          <a:bodyPr wrap="square" lIns="0" tIns="0" rIns="0" bIns="0" rtlCol="0" anchor="t"/>
-          <a:lstStyle/>
-          <a:p>
-            <a:pPr marL="342900" indent="-342900">
-              <a:spcAft>
-                <a:spcPts val="800"/>
-              </a:spcAft>
-              <a:buSzPct val="100000"/>
-              <a:buChar char="•"/>
-            </a:pPr>
-            <a:r>
-              <a:rPr lang="en-US" sz="1500" dirty="0">
-                <a:solidFill>
-                  <a:srgbClr val="3B2A5C"/>
-                </a:solidFill>
-                <a:latin typeface="Calibri" pitchFamily="34" charset="0"/>
-                <a:ea typeface="Calibri" pitchFamily="34" charset="-122"/>
-                <a:cs typeface="Calibri" pitchFamily="34" charset="-120"/>
-              </a:rPr>
-              <a:t>Pasang di Endcap Area Thermal, full terisi sesuai planogram dan mock</a:t>
-            </a:r>
-            <a:endParaRPr lang="en-US" sz="1500" dirty="0"/>
-          </a:p>
-          <a:p>
-            <a:pPr marL="342900" indent="-342900">
-              <a:spcAft>
-                <a:spcPts val="800"/>
-              </a:spcAft>
-              <a:buSzPct val="100000"/>
-              <a:buChar char="•"/>
-            </a:pPr>
-            <a:r>
-              <a:rPr lang="en-US" sz="1500" dirty="0">
-                <a:solidFill>
-                  <a:srgbClr val="3B2A5C"/>
-                </a:solidFill>
-                <a:latin typeface="Calibri" pitchFamily="34" charset="0"/>
-                <a:ea typeface="Calibri" pitchFamily="34" charset="-122"/>
-                <a:cs typeface="Calibri" pitchFamily="34" charset="-120"/>
-              </a:rPr>
-              <a:t>Buka hanya 6 warna sebagai sampel, sisanya tetap tersegel</a:t>
-            </a:r>
-            <a:endParaRPr lang="en-US" sz="1500" dirty="0"/>
-          </a:p>
-          <a:p>
-            <a:pPr marL="342900" indent="-342900">
-              <a:spcAft>
-                <a:spcPts val="800"/>
-              </a:spcAft>
-              <a:buSzPct val="100000"/>
-              <a:buChar char="•"/>
-            </a:pPr>
-            <a:r>
-              <a:rPr lang="en-US" sz="1500" dirty="0">
-                <a:solidFill>
-                  <a:srgbClr val="3B2A5C"/>
-                </a:solidFill>
-                <a:latin typeface="Calibri" pitchFamily="34" charset="0"/>
-                <a:ea typeface="Calibri" pitchFamily="34" charset="-122"/>
-                <a:cs typeface="Calibri" pitchFamily="34" charset="-120"/>
-              </a:rPr>
-              <a:t>Jaga box Secret tetap tersegel</a:t>
-            </a:r>
-            <a:endParaRPr lang="en-US" sz="1500" dirty="0"/>
-          </a:p>
-          <a:p>
-            <a:pPr marL="342900" indent="-342900">
-              <a:spcAft>
-                <a:spcPts val="800"/>
-              </a:spcAft>
-              <a:buSzPct val="100000"/>
-              <a:buChar char="•"/>
-            </a:pPr>
-            <a:r>
-              <a:rPr lang="en-US" sz="1500" dirty="0">
-                <a:solidFill>
-                  <a:srgbClr val="3B2A5C"/>
-                </a:solidFill>
-                <a:latin typeface="Calibri" pitchFamily="34" charset="0"/>
-                <a:ea typeface="Calibri" pitchFamily="34" charset="-122"/>
-                <a:cs typeface="Calibri" pitchFamily="34" charset="-120"/>
-              </a:rPr>
-              <a:t>Rapikan box, logo informa menghadap depan</a:t>
-            </a:r>
-            <a:endParaRPr lang="en-US" sz="1500" dirty="0"/>
-          </a:p>
-          <a:p>
-            <a:pPr marL="342900" indent="-342900">
-              <a:spcAft>
-                <a:spcPts val="800"/>
-              </a:spcAft>
-              <a:buSzPct val="100000"/>
-              <a:buChar char="•"/>
-            </a:pPr>
-            <a:r>
-              <a:rPr lang="en-US" sz="1500" dirty="0">
-                <a:solidFill>
-                  <a:srgbClr val="3B2A5C"/>
-                </a:solidFill>
-                <a:latin typeface="Calibri" pitchFamily="34" charset="0"/>
-                <a:ea typeface="Calibri" pitchFamily="34" charset="-122"/>
-                <a:cs typeface="Calibri" pitchFamily="34" charset="-120"/>
-              </a:rPr>
-              <a:t>Isi ulang rak dari buffer stock sebelum kosong</a:t>
-            </a:r>
-            <a:endParaRPr lang="en-US" sz="1500" dirty="0"/>
-          </a:p>
-          <a:p>
-            <a:pPr marL="342900" indent="-342900">
-              <a:spcAft>
-                <a:spcPts val="800"/>
-              </a:spcAft>
-              <a:buSzPct val="100000"/>
-              <a:buChar char="•"/>
-            </a:pPr>
-            <a:r>
-              <a:rPr lang="en-US" sz="1500" dirty="0">
-                <a:solidFill>
-                  <a:srgbClr val="3B2A5C"/>
-                </a:solidFill>
-                <a:latin typeface="Calibri" pitchFamily="34" charset="0"/>
-                <a:ea typeface="Calibri" pitchFamily="34" charset="-122"/>
-                <a:cs typeface="Calibri" pitchFamily="34" charset="-120"/>
-              </a:rPr>
-              <a:t>Jelaskan ke pelanggan: pilih warna favorit, Secret adalah kejutan</a:t>
-            </a:r>
-            <a:endParaRPr lang="en-US" sz="1500" dirty="0"/>
-          </a:p>
-          <a:p>
-            <a:pPr marL="342900" indent="-342900">
-              <a:spcAft>
-                <a:spcPts val="800"/>
-              </a:spcAft>
-              <a:buSzPct val="100000"/>
-              <a:buChar char="•"/>
-            </a:pPr>
-            <a:r>
-              <a:rPr lang="en-US" sz="1500" dirty="0">
-                <a:solidFill>
-                  <a:srgbClr val="3B2A5C"/>
-                </a:solidFill>
-                <a:latin typeface="Calibri" pitchFamily="34" charset="0"/>
-                <a:ea typeface="Calibri" pitchFamily="34" charset="-122"/>
-                <a:cs typeface="Calibri" pitchFamily="34" charset="-120"/>
-              </a:rPr>
-              <a:t>Cetak POP A4 sementara dari Head Office bila materi komunikasi belum tiba</a:t>
-            </a:r>
-            <a:endParaRPr lang="en-US" sz="1500" dirty="0"/>
-          </a:p>
-        </p:txBody>
-      </p:sp>
-      <p:sp>
-        <p:nvSpPr>
-          <p:cNvPr id="8" name="Shape 6"/>
-          <p:cNvSpPr/>
-          <p:nvPr/>
-        </p:nvSpPr>
-        <p:spPr>
-          <a:xfrm>
-            <a:off x="6263640" y="1645920"/>
-            <a:ext cx="5349240" cy="4754880"/>
-          </a:xfrm>
-          <a:prstGeom prst="roundRect">
-            <a:avLst>
-              <a:gd name="adj" fmla="val 2885"/>
-            </a:avLst>
-          </a:prstGeom>
-          <a:solidFill>
-            <a:srgbClr val="FDEAF3"/>
-          </a:solidFill>
-          <a:ln w="12700">
-            <a:solidFill>
-              <a:srgbClr val="FDEAF3"/>
-            </a:solidFill>
-            <a:prstDash val="solid"/>
-          </a:ln>
-        </p:spPr>
-      </p:sp>
-      <p:sp>
-        <p:nvSpPr>
-          <p:cNvPr id="9" name="Shape 7"/>
-          <p:cNvSpPr/>
-          <p:nvPr/>
-        </p:nvSpPr>
-        <p:spPr>
-          <a:xfrm>
-            <a:off x="6537960" y="1828800"/>
-            <a:ext cx="1371600" cy="457200"/>
-          </a:xfrm>
-          <a:prstGeom prst="roundRect">
-            <a:avLst>
-              <a:gd name="adj" fmla="val 50000"/>
-            </a:avLst>
-          </a:prstGeom>
-          <a:solidFill>
-            <a:srgbClr val="F27BB0"/>
-          </a:solidFill>
-          <a:ln w="12700">
-            <a:solidFill>
-              <a:srgbClr val="F27BB0"/>
-            </a:solidFill>
-            <a:prstDash val="solid"/>
-          </a:ln>
-        </p:spPr>
-      </p:sp>
-      <p:sp>
-        <p:nvSpPr>
-          <p:cNvPr id="10" name="Text 8"/>
-          <p:cNvSpPr txBox="1"/>
-          <p:nvPr/>
-        </p:nvSpPr>
-        <p:spPr>
-          <a:xfrm>
-            <a:off x="6537960" y="1828800"/>
-            <a:ext cx="1371600" cy="457200"/>
-          </a:xfrm>
-          <a:prstGeom prst="rect">
-            <a:avLst/>
-          </a:prstGeom>
-          <a:noFill/>
-          <a:ln/>
-        </p:spPr>
-        <p:txBody>
-          <a:bodyPr wrap="square" lIns="0" tIns="0" rIns="0" bIns="0" rtlCol="0" anchor="ctr"/>
-          <a:lstStyle/>
-          <a:p>
-            <a:pPr algn="ctr" indent="0" marL="0">
-              <a:buNone/>
-            </a:pPr>
-            <a:r>
-              <a:rPr lang="en-US" sz="1800" b="1" dirty="0">
-                <a:solidFill>
-                  <a:srgbClr val="FFFFFF"/>
-                </a:solidFill>
-                <a:latin typeface="Calibri" pitchFamily="34" charset="0"/>
-                <a:ea typeface="Calibri" pitchFamily="34" charset="-122"/>
-                <a:cs typeface="Calibri" pitchFamily="34" charset="-120"/>
-              </a:rPr>
-              <a:t>DON'T</a:t>
-            </a:r>
-            <a:endParaRPr lang="en-US" sz="1800" dirty="0"/>
-          </a:p>
-        </p:txBody>
-      </p:sp>
-      <p:sp>
-        <p:nvSpPr>
-          <p:cNvPr id="11" name="Text 9"/>
-          <p:cNvSpPr txBox="1"/>
-          <p:nvPr/>
-        </p:nvSpPr>
-        <p:spPr>
-          <a:xfrm>
-            <a:off x="6537960" y="2514600"/>
-            <a:ext cx="4800600" cy="3749040"/>
-          </a:xfrm>
-          <a:prstGeom prst="rect">
-            <a:avLst/>
-          </a:prstGeom>
-          <a:noFill/>
-          <a:ln/>
-        </p:spPr>
-        <p:txBody>
-          <a:bodyPr wrap="square" lIns="0" tIns="0" rIns="0" bIns="0" rtlCol="0" anchor="t"/>
-          <a:lstStyle/>
-          <a:p>
-            <a:pPr marL="342900" indent="-342900">
-              <a:spcAft>
-                <a:spcPts val="800"/>
-              </a:spcAft>
-              <a:buSzPct val="100000"/>
-              <a:buChar char="•"/>
-            </a:pPr>
-            <a:r>
-              <a:rPr lang="en-US" sz="1500" dirty="0">
-                <a:solidFill>
-                  <a:srgbClr val="3B2A5C"/>
-                </a:solidFill>
-                <a:latin typeface="Calibri" pitchFamily="34" charset="0"/>
-                <a:ea typeface="Calibri" pitchFamily="34" charset="-122"/>
-                <a:cs typeface="Calibri" pitchFamily="34" charset="-120"/>
-              </a:rPr>
-              <a:t>Jangan taruh di luar endcap Thermal atau campur dengan produk lain</a:t>
-            </a:r>
-            <a:endParaRPr lang="en-US" sz="1500" dirty="0"/>
-          </a:p>
-          <a:p>
-            <a:pPr marL="342900" indent="-342900">
-              <a:spcAft>
-                <a:spcPts val="800"/>
-              </a:spcAft>
-              <a:buSzPct val="100000"/>
-              <a:buChar char="•"/>
-            </a:pPr>
-            <a:r>
-              <a:rPr lang="en-US" sz="1500" dirty="0">
-                <a:solidFill>
-                  <a:srgbClr val="3B2A5C"/>
-                </a:solidFill>
-                <a:latin typeface="Calibri" pitchFamily="34" charset="0"/>
-                <a:ea typeface="Calibri" pitchFamily="34" charset="-122"/>
-                <a:cs typeface="Calibri" pitchFamily="34" charset="-120"/>
-              </a:rPr>
-              <a:t>Jangan biarkan rak kosong atau terisi sebagian</a:t>
-            </a:r>
-            <a:endParaRPr lang="en-US" sz="1500" dirty="0"/>
-          </a:p>
-          <a:p>
-            <a:pPr marL="342900" indent="-342900">
-              <a:spcAft>
-                <a:spcPts val="800"/>
-              </a:spcAft>
-              <a:buSzPct val="100000"/>
-              <a:buChar char="•"/>
-            </a:pPr>
-            <a:r>
-              <a:rPr lang="en-US" sz="1500" dirty="0">
-                <a:solidFill>
-                  <a:srgbClr val="3B2A5C"/>
-                </a:solidFill>
-                <a:latin typeface="Calibri" pitchFamily="34" charset="0"/>
-                <a:ea typeface="Calibri" pitchFamily="34" charset="-122"/>
-                <a:cs typeface="Calibri" pitchFamily="34" charset="-120"/>
-              </a:rPr>
-              <a:t>Jangan buka atau sobek box selain sampel 6 warna</a:t>
-            </a:r>
-            <a:endParaRPr lang="en-US" sz="1500" dirty="0"/>
-          </a:p>
-          <a:p>
-            <a:pPr marL="342900" indent="-342900">
-              <a:spcAft>
-                <a:spcPts val="800"/>
-              </a:spcAft>
-              <a:buSzPct val="100000"/>
-              <a:buChar char="•"/>
-            </a:pPr>
-            <a:r>
-              <a:rPr lang="en-US" sz="1500" dirty="0">
-                <a:solidFill>
-                  <a:srgbClr val="3B2A5C"/>
-                </a:solidFill>
-                <a:latin typeface="Calibri" pitchFamily="34" charset="0"/>
-                <a:ea typeface="Calibri" pitchFamily="34" charset="-122"/>
-                <a:cs typeface="Calibri" pitchFamily="34" charset="-120"/>
-              </a:rPr>
-              <a:t>Jangan bocorkan isi box tersegel (ditimbang, diguncang, atau diberi petunjuk)</a:t>
-            </a:r>
-            <a:endParaRPr lang="en-US" sz="1500" dirty="0"/>
-          </a:p>
-          <a:p>
-            <a:pPr marL="342900" indent="-342900">
-              <a:spcAft>
-                <a:spcPts val="800"/>
-              </a:spcAft>
-              <a:buSzPct val="100000"/>
-              <a:buChar char="•"/>
-            </a:pPr>
-            <a:r>
-              <a:rPr lang="en-US" sz="1500" dirty="0">
-                <a:solidFill>
-                  <a:srgbClr val="3B2A5C"/>
-                </a:solidFill>
-                <a:latin typeface="Calibri" pitchFamily="34" charset="0"/>
-                <a:ea typeface="Calibri" pitchFamily="34" charset="-122"/>
-                <a:cs typeface="Calibri" pitchFamily="34" charset="-120"/>
-              </a:rPr>
-              <a:t>Jangan ubah susunan, qty, atau tinggi rak</a:t>
-            </a:r>
-            <a:endParaRPr lang="en-US" sz="1500" dirty="0"/>
-          </a:p>
-          <a:p>
-            <a:pPr marL="342900" indent="-342900">
-              <a:spcAft>
-                <a:spcPts val="800"/>
-              </a:spcAft>
-              <a:buSzPct val="100000"/>
-              <a:buChar char="•"/>
-            </a:pPr>
-            <a:r>
-              <a:rPr lang="en-US" sz="1500" dirty="0">
-                <a:solidFill>
-                  <a:srgbClr val="3B2A5C"/>
-                </a:solidFill>
-                <a:latin typeface="Calibri" pitchFamily="34" charset="0"/>
-                <a:ea typeface="Calibri" pitchFamily="34" charset="-122"/>
-                <a:cs typeface="Calibri" pitchFamily="34" charset="-120"/>
-              </a:rPr>
-              <a:t>Jangan jual unit sampel yang sudah dibuka sebagai produk baru</a:t>
-            </a:r>
-            <a:endParaRPr lang="en-US" sz="1500" dirty="0"/>
-          </a:p>
-          <a:p>
-            <a:pPr marL="342900" indent="-342900">
-              <a:spcAft>
-                <a:spcPts val="800"/>
-              </a:spcAft>
-              <a:buSzPct val="100000"/>
-              <a:buChar char="•"/>
-            </a:pPr>
-            <a:r>
-              <a:rPr lang="en-US" sz="1500" dirty="0">
-                <a:solidFill>
-                  <a:srgbClr val="3B2A5C"/>
-                </a:solidFill>
-                <a:latin typeface="Calibri" pitchFamily="34" charset="0"/>
-                <a:ea typeface="Calibri" pitchFamily="34" charset="-122"/>
-                <a:cs typeface="Calibri" pitchFamily="34" charset="-120"/>
-              </a:rPr>
-              <a:t>Jangan cetak POP sementara selain di percetakan</a:t>
-            </a:r>
-            <a:endParaRPr lang="en-US" sz="1500" dirty="0"/>
           </a:p>
         </p:txBody>
       </p:sp>

</xml_diff>